<commit_message>
feat: update Week 2, Session 1 PowerPoint presentation with new content revisions to enhance educational clarity and effectiveness
</commit_message>
<xml_diff>
--- a/web-presentation/pdf-exports/Week2-Session1-Deep-Learning.pptx
+++ b/web-presentation/pdf-exports/Week2-Session1-Deep-Learning.pptx
@@ -83,6 +83,7 @@
     <p:sldId id="331" r:id="rId82"/>
     <p:sldId id="332" r:id="rId83"/>
     <p:sldId id="333" r:id="rId84"/>
+    <p:sldId id="334" r:id="rId85"/>
   </p:sldIdLst>
   <p:sldSz cx="12191695" cy="6858000" type="screen4x3"/>
   <p:notesSz cx="6858000" cy="9144000"/>
@@ -4025,7 +4026,7 @@
                 <a:ea typeface="DIN Next LT W23"/>
                 <a:cs typeface="DIN Next LT W23"/>
               </a:rPr>
-              <a:t>10  /  78</a:t>
+              <a:t>10  /  79</a:t>
             </a:r>
           </a:p>
         </p:txBody>
@@ -4693,7 +4694,7 @@
                 <a:ea typeface="DIN Next LT W23"/>
                 <a:cs typeface="DIN Next LT W23"/>
               </a:rPr>
-              <a:t>11  /  78</a:t>
+              <a:t>11  /  79</a:t>
             </a:r>
           </a:p>
         </p:txBody>
@@ -5167,7 +5168,7 @@
                 <a:ea typeface="DIN Next LT W23"/>
                 <a:cs typeface="DIN Next LT W23"/>
               </a:rPr>
-              <a:t>12  /  78</a:t>
+              <a:t>12  /  79</a:t>
             </a:r>
           </a:p>
         </p:txBody>
@@ -5756,7 +5757,7 @@
                 <a:ea typeface="DIN Next LT W23"/>
                 <a:cs typeface="DIN Next LT W23"/>
               </a:rPr>
-              <a:t>13  /  78</a:t>
+              <a:t>13  /  79</a:t>
             </a:r>
           </a:p>
         </p:txBody>
@@ -6230,7 +6231,7 @@
                 <a:ea typeface="DIN Next LT W23"/>
                 <a:cs typeface="DIN Next LT W23"/>
               </a:rPr>
-              <a:t>14  /  78</a:t>
+              <a:t>14  /  79</a:t>
             </a:r>
           </a:p>
         </p:txBody>
@@ -6898,7 +6899,7 @@
                 <a:ea typeface="DIN Next LT W23"/>
                 <a:cs typeface="DIN Next LT W23"/>
               </a:rPr>
-              <a:t>15  /  78</a:t>
+              <a:t>15  /  79</a:t>
             </a:r>
           </a:p>
         </p:txBody>
@@ -7487,7 +7488,7 @@
                 <a:ea typeface="DIN Next LT W23"/>
                 <a:cs typeface="DIN Next LT W23"/>
               </a:rPr>
-              <a:t>16  /  78</a:t>
+              <a:t>16  /  79</a:t>
             </a:r>
           </a:p>
         </p:txBody>
@@ -8307,7 +8308,7 @@
                 <a:ea typeface="DIN Next LT W23"/>
                 <a:cs typeface="DIN Next LT W23"/>
               </a:rPr>
-              <a:t>17  /  78</a:t>
+              <a:t>17  /  79</a:t>
             </a:r>
           </a:p>
         </p:txBody>
@@ -9086,7 +9087,7 @@
                 <a:ea typeface="DIN Next LT W23"/>
                 <a:cs typeface="DIN Next LT W23"/>
               </a:rPr>
-              <a:t>18  /  78</a:t>
+              <a:t>18  /  79</a:t>
             </a:r>
           </a:p>
         </p:txBody>
@@ -9802,7 +9803,7 @@
                 <a:ea typeface="DIN Next LT W23"/>
                 <a:cs typeface="DIN Next LT W23"/>
               </a:rPr>
-              <a:t>19  /  78</a:t>
+              <a:t>19  /  79</a:t>
             </a:r>
           </a:p>
         </p:txBody>
@@ -11721,7 +11722,7 @@
                 <a:ea typeface="DIN Next LT W23"/>
                 <a:cs typeface="DIN Next LT W23"/>
               </a:rPr>
-              <a:t>02  /  78</a:t>
+              <a:t>02  /  79</a:t>
             </a:r>
           </a:p>
         </p:txBody>
@@ -12385,7 +12386,7 @@
                 <a:ea typeface="DIN Next LT W23"/>
                 <a:cs typeface="DIN Next LT W23"/>
               </a:rPr>
-              <a:t>20  /  78</a:t>
+              <a:t>20  /  79</a:t>
             </a:r>
           </a:p>
         </p:txBody>
@@ -13048,7 +13049,7 @@
                 <a:ea typeface="DIN Next LT W23"/>
                 <a:cs typeface="DIN Next LT W23"/>
               </a:rPr>
-              <a:t>21  /  78</a:t>
+              <a:t>21  /  79</a:t>
             </a:r>
           </a:p>
         </p:txBody>
@@ -13880,7 +13881,7 @@
                 <a:ea typeface="DIN Next LT W23"/>
                 <a:cs typeface="DIN Next LT W23"/>
               </a:rPr>
-              <a:t>22  /  78</a:t>
+              <a:t>22  /  79</a:t>
             </a:r>
           </a:p>
         </p:txBody>
@@ -14469,7 +14470,7 @@
                 <a:ea typeface="DIN Next LT W23"/>
                 <a:cs typeface="DIN Next LT W23"/>
               </a:rPr>
-              <a:t>23  /  78</a:t>
+              <a:t>23  /  79</a:t>
             </a:r>
           </a:p>
         </p:txBody>
@@ -15174,7 +15175,7 @@
                 <a:ea typeface="DIN Next LT W23"/>
                 <a:cs typeface="DIN Next LT W23"/>
               </a:rPr>
-              <a:t>24  /  78</a:t>
+              <a:t>24  /  79</a:t>
             </a:r>
           </a:p>
         </p:txBody>
@@ -15852,7 +15853,7 @@
                 <a:ea typeface="DIN Next LT W23"/>
                 <a:cs typeface="DIN Next LT W23"/>
               </a:rPr>
-              <a:t>25  /  78</a:t>
+              <a:t>25  /  79</a:t>
             </a:r>
           </a:p>
         </p:txBody>
@@ -16372,7 +16373,7 @@
                 <a:ea typeface="DIN Next LT W23"/>
                 <a:cs typeface="DIN Next LT W23"/>
               </a:rPr>
-              <a:t>26  /  78</a:t>
+              <a:t>26  /  79</a:t>
             </a:r>
           </a:p>
         </p:txBody>
@@ -16846,7 +16847,7 @@
                 <a:ea typeface="DIN Next LT W23"/>
                 <a:cs typeface="DIN Next LT W23"/>
               </a:rPr>
-              <a:t>27  /  78</a:t>
+              <a:t>27  /  79</a:t>
             </a:r>
           </a:p>
         </p:txBody>
@@ -17435,7 +17436,7 @@
                 <a:ea typeface="DIN Next LT W23"/>
                 <a:cs typeface="DIN Next LT W23"/>
               </a:rPr>
-              <a:t>28  /  78</a:t>
+              <a:t>28  /  79</a:t>
             </a:r>
           </a:p>
         </p:txBody>
@@ -18113,7 +18114,7 @@
                 <a:ea typeface="DIN Next LT W23"/>
                 <a:cs typeface="DIN Next LT W23"/>
               </a:rPr>
-              <a:t>29  /  78</a:t>
+              <a:t>29  /  79</a:t>
             </a:r>
           </a:p>
         </p:txBody>
@@ -18986,7 +18987,7 @@
                 <a:ea typeface="DIN Next LT W23"/>
                 <a:cs typeface="DIN Next LT W23"/>
               </a:rPr>
-              <a:t>03  /  78</a:t>
+              <a:t>03  /  79</a:t>
             </a:r>
           </a:p>
         </p:txBody>
@@ -19650,7 +19651,7 @@
                 <a:ea typeface="DIN Next LT W23"/>
                 <a:cs typeface="DIN Next LT W23"/>
               </a:rPr>
-              <a:t>30  /  78</a:t>
+              <a:t>30  /  79</a:t>
             </a:r>
           </a:p>
         </p:txBody>
@@ -20124,7 +20125,7 @@
                 <a:ea typeface="DIN Next LT W23"/>
                 <a:cs typeface="DIN Next LT W23"/>
               </a:rPr>
-              <a:t>31  /  78</a:t>
+              <a:t>31  /  79</a:t>
             </a:r>
           </a:p>
         </p:txBody>
@@ -20713,7 +20714,7 @@
                 <a:ea typeface="DIN Next LT W23"/>
                 <a:cs typeface="DIN Next LT W23"/>
               </a:rPr>
-              <a:t>32  /  78</a:t>
+              <a:t>32  /  79</a:t>
             </a:r>
           </a:p>
         </p:txBody>
@@ -21187,7 +21188,7 @@
                 <a:ea typeface="DIN Next LT W23"/>
                 <a:cs typeface="DIN Next LT W23"/>
               </a:rPr>
-              <a:t>33  /  78</a:t>
+              <a:t>33  /  79</a:t>
             </a:r>
           </a:p>
         </p:txBody>
@@ -22019,7 +22020,7 @@
                 <a:ea typeface="DIN Next LT W23"/>
                 <a:cs typeface="DIN Next LT W23"/>
               </a:rPr>
-              <a:t>34  /  78</a:t>
+              <a:t>34  /  79</a:t>
             </a:r>
           </a:p>
         </p:txBody>
@@ -22683,7 +22684,7 @@
                 <a:ea typeface="DIN Next LT W23"/>
                 <a:cs typeface="DIN Next LT W23"/>
               </a:rPr>
-              <a:t>35  /  78</a:t>
+              <a:t>35  /  79</a:t>
             </a:r>
           </a:p>
         </p:txBody>
@@ -23157,7 +23158,7 @@
                 <a:ea typeface="DIN Next LT W23"/>
                 <a:cs typeface="DIN Next LT W23"/>
               </a:rPr>
-              <a:t>36  /  78</a:t>
+              <a:t>36  /  79</a:t>
             </a:r>
           </a:p>
         </p:txBody>
@@ -23746,7 +23747,7 @@
                 <a:ea typeface="DIN Next LT W23"/>
                 <a:cs typeface="DIN Next LT W23"/>
               </a:rPr>
-              <a:t>37  /  78</a:t>
+              <a:t>37  /  79</a:t>
             </a:r>
           </a:p>
         </p:txBody>
@@ -24331,7 +24332,7 @@
                 <a:ea typeface="DIN Next LT W23"/>
                 <a:cs typeface="DIN Next LT W23"/>
               </a:rPr>
-              <a:t>38  /  78</a:t>
+              <a:t>38  /  79</a:t>
             </a:r>
           </a:p>
         </p:txBody>
@@ -24805,7 +24806,7 @@
                 <a:ea typeface="DIN Next LT W23"/>
                 <a:cs typeface="DIN Next LT W23"/>
               </a:rPr>
-              <a:t>39  /  78</a:t>
+              <a:t>39  /  79</a:t>
             </a:r>
           </a:p>
         </p:txBody>
@@ -25616,7 +25617,7 @@
                 <a:ea typeface="DIN Next LT W23"/>
                 <a:cs typeface="DIN Next LT W23"/>
               </a:rPr>
-              <a:t>04  /  78</a:t>
+              <a:t>04  /  79</a:t>
             </a:r>
           </a:p>
         </p:txBody>
@@ -26205,7 +26206,7 @@
                 <a:ea typeface="DIN Next LT W23"/>
                 <a:cs typeface="DIN Next LT W23"/>
               </a:rPr>
-              <a:t>40  /  78</a:t>
+              <a:t>40  /  79</a:t>
             </a:r>
           </a:p>
         </p:txBody>
@@ -26883,7 +26884,7 @@
                 <a:ea typeface="DIN Next LT W23"/>
                 <a:cs typeface="DIN Next LT W23"/>
               </a:rPr>
-              <a:t>41  /  78</a:t>
+              <a:t>41  /  79</a:t>
             </a:r>
           </a:p>
         </p:txBody>
@@ -27357,7 +27358,7 @@
                 <a:ea typeface="DIN Next LT W23"/>
                 <a:cs typeface="DIN Next LT W23"/>
               </a:rPr>
-              <a:t>42  /  78</a:t>
+              <a:t>42  /  79</a:t>
             </a:r>
           </a:p>
         </p:txBody>
@@ -28025,7 +28026,7 @@
                 <a:ea typeface="DIN Next LT W23"/>
                 <a:cs typeface="DIN Next LT W23"/>
               </a:rPr>
-              <a:t>43  /  78</a:t>
+              <a:t>43  /  79</a:t>
             </a:r>
           </a:p>
         </p:txBody>
@@ -28730,7 +28731,7 @@
                 <a:ea typeface="DIN Next LT W23"/>
                 <a:cs typeface="DIN Next LT W23"/>
               </a:rPr>
-              <a:t>44  /  78</a:t>
+              <a:t>44  /  79</a:t>
             </a:r>
           </a:p>
         </p:txBody>
@@ -29398,7 +29399,7 @@
                 <a:ea typeface="DIN Next LT W23"/>
                 <a:cs typeface="DIN Next LT W23"/>
               </a:rPr>
-              <a:t>45  /  78</a:t>
+              <a:t>45  /  79</a:t>
             </a:r>
           </a:p>
         </p:txBody>
@@ -29946,7 +29947,7 @@
                 <a:ea typeface="DIN Next LT W23"/>
                 <a:cs typeface="DIN Next LT W23"/>
               </a:rPr>
-              <a:t>46  /  78</a:t>
+              <a:t>46  /  79</a:t>
             </a:r>
           </a:p>
         </p:txBody>
@@ -30420,7 +30421,7 @@
                 <a:ea typeface="DIN Next LT W23"/>
                 <a:cs typeface="DIN Next LT W23"/>
               </a:rPr>
-              <a:t>47  /  78</a:t>
+              <a:t>47  /  79</a:t>
             </a:r>
           </a:p>
         </p:txBody>
@@ -30972,7 +30973,7 @@
                 <a:ea typeface="DIN Next LT W23"/>
                 <a:cs typeface="DIN Next LT W23"/>
               </a:rPr>
-              <a:t>48  /  78</a:t>
+              <a:t>48  /  79</a:t>
             </a:r>
           </a:p>
         </p:txBody>
@@ -31592,7 +31593,7 @@
                 <a:ea typeface="DIN Next LT W23"/>
                 <a:cs typeface="DIN Next LT W23"/>
               </a:rPr>
-              <a:t>49  /  78</a:t>
+              <a:t>49  /  79</a:t>
             </a:r>
           </a:p>
         </p:txBody>
@@ -32371,7 +32372,7 @@
                 <a:ea typeface="DIN Next LT W23"/>
                 <a:cs typeface="DIN Next LT W23"/>
               </a:rPr>
-              <a:t>05  /  78</a:t>
+              <a:t>05  /  79</a:t>
             </a:r>
           </a:p>
         </p:txBody>
@@ -32886,7 +32887,7 @@
                 <a:ea typeface="DIN Next LT W23"/>
                 <a:cs typeface="DIN Next LT W23"/>
               </a:rPr>
-              <a:t>50  /  78</a:t>
+              <a:t>50  /  79</a:t>
             </a:r>
           </a:p>
         </p:txBody>
@@ -33471,7 +33472,7 @@
                 <a:ea typeface="DIN Next LT W23"/>
                 <a:cs typeface="DIN Next LT W23"/>
               </a:rPr>
-              <a:t>51  /  78</a:t>
+              <a:t>51  /  79</a:t>
             </a:r>
           </a:p>
         </p:txBody>
@@ -34060,7 +34061,7 @@
                 <a:ea typeface="DIN Next LT W23"/>
                 <a:cs typeface="DIN Next LT W23"/>
               </a:rPr>
-              <a:t>52  /  78</a:t>
+              <a:t>52  /  79</a:t>
             </a:r>
           </a:p>
         </p:txBody>
@@ -34534,7 +34535,7 @@
                 <a:ea typeface="DIN Next LT W23"/>
                 <a:cs typeface="DIN Next LT W23"/>
               </a:rPr>
-              <a:t>53  /  78</a:t>
+              <a:t>53  /  79</a:t>
             </a:r>
           </a:p>
         </p:txBody>
@@ -35305,7 +35306,7 @@
                 <a:ea typeface="DIN Next LT W23"/>
                 <a:cs typeface="DIN Next LT W23"/>
               </a:rPr>
-              <a:t>54  /  78</a:t>
+              <a:t>54  /  79</a:t>
             </a:r>
           </a:p>
         </p:txBody>
@@ -35894,7 +35895,7 @@
                 <a:ea typeface="DIN Next LT W23"/>
                 <a:cs typeface="DIN Next LT W23"/>
               </a:rPr>
-              <a:t>55  /  78</a:t>
+              <a:t>55  /  79</a:t>
             </a:r>
           </a:p>
         </p:txBody>
@@ -36572,7 +36573,7 @@
                 <a:ea typeface="DIN Next LT W23"/>
                 <a:cs typeface="DIN Next LT W23"/>
               </a:rPr>
-              <a:t>56  /  78</a:t>
+              <a:t>56  /  79</a:t>
             </a:r>
           </a:p>
         </p:txBody>
@@ -37198,7 +37199,7 @@
                 <a:ea typeface="DIN Next LT W23"/>
                 <a:cs typeface="DIN Next LT W23"/>
               </a:rPr>
-              <a:t>57  /  78</a:t>
+              <a:t>57  /  79</a:t>
             </a:r>
           </a:p>
         </p:txBody>
@@ -37672,7 +37673,7 @@
                 <a:ea typeface="DIN Next LT W23"/>
                 <a:cs typeface="DIN Next LT W23"/>
               </a:rPr>
-              <a:t>58  /  78</a:t>
+              <a:t>58  /  79</a:t>
             </a:r>
           </a:p>
         </p:txBody>
@@ -38433,7 +38434,7 @@
                 <a:ea typeface="DIN Next LT W23"/>
                 <a:cs typeface="DIN Next LT W23"/>
               </a:rPr>
-              <a:t>59  /  78</a:t>
+              <a:t>59  /  79</a:t>
             </a:r>
           </a:p>
         </p:txBody>
@@ -38944,7 +38945,7 @@
                 <a:ea typeface="DIN Next LT W23"/>
                 <a:cs typeface="DIN Next LT W23"/>
               </a:rPr>
-              <a:t>06  /  78</a:t>
+              <a:t>06  /  79</a:t>
             </a:r>
           </a:p>
         </p:txBody>
@@ -39418,7 +39419,7 @@
                 <a:ea typeface="DIN Next LT W23"/>
                 <a:cs typeface="DIN Next LT W23"/>
               </a:rPr>
-              <a:t>60  /  78</a:t>
+              <a:t>60  /  79</a:t>
             </a:r>
           </a:p>
         </p:txBody>
@@ -40086,7 +40087,7 @@
                 <a:ea typeface="DIN Next LT W23"/>
                 <a:cs typeface="DIN Next LT W23"/>
               </a:rPr>
-              <a:t>61  /  78</a:t>
+              <a:t>61  /  79</a:t>
             </a:r>
           </a:p>
         </p:txBody>
@@ -40693,7 +40694,7 @@
                 <a:ea typeface="DIN Next LT W23"/>
                 <a:cs typeface="DIN Next LT W23"/>
               </a:rPr>
-              <a:t>62  /  78</a:t>
+              <a:t>62  /  79</a:t>
             </a:r>
           </a:p>
         </p:txBody>
@@ -41472,7 +41473,7 @@
                 <a:ea typeface="DIN Next LT W23"/>
                 <a:cs typeface="DIN Next LT W23"/>
               </a:rPr>
-              <a:t>63  /  78</a:t>
+              <a:t>63  /  79</a:t>
             </a:r>
           </a:p>
         </p:txBody>
@@ -41983,7 +41984,7 @@
                 <a:ea typeface="DIN Next LT W23"/>
                 <a:cs typeface="DIN Next LT W23"/>
               </a:rPr>
-              <a:t>64  /  78</a:t>
+              <a:t>64  /  79</a:t>
             </a:r>
           </a:p>
         </p:txBody>
@@ -42699,7 +42700,7 @@
                 <a:ea typeface="DIN Next LT W23"/>
                 <a:cs typeface="DIN Next LT W23"/>
               </a:rPr>
-              <a:t>65  /  78</a:t>
+              <a:t>65  /  79</a:t>
             </a:r>
           </a:p>
         </p:txBody>
@@ -43210,7 +43211,7 @@
                 <a:ea typeface="DIN Next LT W23"/>
                 <a:cs typeface="DIN Next LT W23"/>
               </a:rPr>
-              <a:t>66  /  78</a:t>
+              <a:t>66  /  79</a:t>
             </a:r>
           </a:p>
         </p:txBody>
@@ -43952,7 +43953,7 @@
                 <a:ea typeface="DIN Next LT W23"/>
                 <a:cs typeface="DIN Next LT W23"/>
               </a:rPr>
-              <a:t>67  /  78</a:t>
+              <a:t>67  /  79</a:t>
             </a:r>
           </a:p>
         </p:txBody>
@@ -44426,7 +44427,7 @@
                 <a:ea typeface="DIN Next LT W23"/>
                 <a:cs typeface="DIN Next LT W23"/>
               </a:rPr>
-              <a:t>68  /  78</a:t>
+              <a:t>68  /  79</a:t>
             </a:r>
           </a:p>
         </p:txBody>
@@ -44937,7 +44938,7 @@
                 <a:ea typeface="DIN Next LT W23"/>
                 <a:cs typeface="DIN Next LT W23"/>
               </a:rPr>
-              <a:t>69  /  78</a:t>
+              <a:t>69  /  79</a:t>
             </a:r>
           </a:p>
         </p:txBody>
@@ -45642,7 +45643,7 @@
                 <a:ea typeface="DIN Next LT W23"/>
                 <a:cs typeface="DIN Next LT W23"/>
               </a:rPr>
-              <a:t>07  /  78</a:t>
+              <a:t>07  /  79</a:t>
             </a:r>
           </a:p>
         </p:txBody>
@@ -46310,7 +46311,7 @@
                 <a:ea typeface="DIN Next LT W23"/>
                 <a:cs typeface="DIN Next LT W23"/>
               </a:rPr>
-              <a:t>70  /  78</a:t>
+              <a:t>70  /  79</a:t>
             </a:r>
           </a:p>
         </p:txBody>
@@ -46904,7 +46905,7 @@
                 <a:ea typeface="DIN Next LT W23"/>
                 <a:cs typeface="DIN Next LT W23"/>
               </a:rPr>
-              <a:t>71  /  78</a:t>
+              <a:t>71  /  79</a:t>
             </a:r>
           </a:p>
         </p:txBody>
@@ -47116,7 +47117,7 @@
                 <a:ea typeface="DIN Next LT W23"/>
                 <a:cs typeface="DIN Next LT W23"/>
               </a:rPr>
-              <a:t>Regularization Toolkit</a:t>
+              <a:t>Regularization: Dropout, Weight Decay, and Early Stopping</a:t>
             </a:r>
           </a:p>
         </p:txBody>
@@ -47153,7 +47154,596 @@
                 <a:ea typeface="DIN Next LT W23"/>
                 <a:cs typeface="DIN Next LT W23"/>
               </a:rPr>
-              <a:t>Three Levers You Will Use Together</a:t>
+              <a:t>Constrain Capacity to Prevent Overfitting</a:t>
+            </a:r>
+          </a:p>
+        </p:txBody>
+      </p:sp>
+      <p:sp>
+        <p:nvSpPr>
+          <p:cNvPr id="8" name="TextBox 7"/>
+          <p:cNvSpPr txBox="1"/>
+          <p:nvPr/>
+        </p:nvSpPr>
+        <p:spPr>
+          <a:xfrm>
+            <a:off x="548640" y="2148840"/>
+            <a:ext cx="320040" cy="411480"/>
+          </a:xfrm>
+          <a:prstGeom prst="rect">
+            <a:avLst/>
+          </a:prstGeom>
+          <a:noFill/>
+        </p:spPr>
+        <p:txBody>
+          <a:bodyPr wrap="square" anchor="t">
+            <a:spAutoFit/>
+          </a:bodyPr>
+          <a:lstStyle/>
+          <a:p>
+            <a:pPr algn="l"/>
+            <a:r>
+              <a:rPr sz="1700" b="0">
+                <a:solidFill>
+                  <a:srgbClr val="9E59CD"/>
+                </a:solidFill>
+                <a:latin typeface="DIN Next LT W23"/>
+                <a:ea typeface="DIN Next LT W23"/>
+                <a:cs typeface="DIN Next LT W23"/>
+              </a:rPr>
+              <a:t>–</a:t>
+            </a:r>
+          </a:p>
+        </p:txBody>
+      </p:sp>
+      <p:sp>
+        <p:nvSpPr>
+          <p:cNvPr id="9" name="TextBox 8"/>
+          <p:cNvSpPr txBox="1"/>
+          <p:nvPr/>
+        </p:nvSpPr>
+        <p:spPr>
+          <a:xfrm>
+            <a:off x="914400" y="2148840"/>
+            <a:ext cx="9875519" cy="411480"/>
+          </a:xfrm>
+          <a:prstGeom prst="rect">
+            <a:avLst/>
+          </a:prstGeom>
+          <a:noFill/>
+        </p:spPr>
+        <p:txBody>
+          <a:bodyPr wrap="square" anchor="t">
+            <a:spAutoFit/>
+          </a:bodyPr>
+          <a:lstStyle/>
+          <a:p>
+            <a:pPr algn="l"/>
+            <a:r>
+              <a:rPr sz="1700" b="0">
+                <a:solidFill>
+                  <a:srgbClr val="121018"/>
+                </a:solidFill>
+                <a:latin typeface="DIN Next LT W23"/>
+                <a:ea typeface="DIN Next LT W23"/>
+                <a:cs typeface="DIN Next LT W23"/>
+              </a:rPr>
+              <a:t>Dropout acts as a powerful implicit ensemble method; disabled during inference (evaluation mode).</a:t>
+            </a:r>
+          </a:p>
+        </p:txBody>
+      </p:sp>
+      <p:sp>
+        <p:nvSpPr>
+          <p:cNvPr id="10" name="TextBox 9"/>
+          <p:cNvSpPr txBox="1"/>
+          <p:nvPr/>
+        </p:nvSpPr>
+        <p:spPr>
+          <a:xfrm>
+            <a:off x="548640" y="2715768"/>
+            <a:ext cx="320040" cy="411480"/>
+          </a:xfrm>
+          <a:prstGeom prst="rect">
+            <a:avLst/>
+          </a:prstGeom>
+          <a:noFill/>
+        </p:spPr>
+        <p:txBody>
+          <a:bodyPr wrap="square" anchor="t">
+            <a:spAutoFit/>
+          </a:bodyPr>
+          <a:lstStyle/>
+          <a:p>
+            <a:pPr algn="l"/>
+            <a:r>
+              <a:rPr sz="1700" b="0">
+                <a:solidFill>
+                  <a:srgbClr val="9E59CD"/>
+                </a:solidFill>
+                <a:latin typeface="DIN Next LT W23"/>
+                <a:ea typeface="DIN Next LT W23"/>
+                <a:cs typeface="DIN Next LT W23"/>
+              </a:rPr>
+              <a:t>–</a:t>
+            </a:r>
+          </a:p>
+        </p:txBody>
+      </p:sp>
+      <p:sp>
+        <p:nvSpPr>
+          <p:cNvPr id="11" name="TextBox 10"/>
+          <p:cNvSpPr txBox="1"/>
+          <p:nvPr/>
+        </p:nvSpPr>
+        <p:spPr>
+          <a:xfrm>
+            <a:off x="914400" y="2715768"/>
+            <a:ext cx="9875519" cy="411480"/>
+          </a:xfrm>
+          <a:prstGeom prst="rect">
+            <a:avLst/>
+          </a:prstGeom>
+          <a:noFill/>
+        </p:spPr>
+        <p:txBody>
+          <a:bodyPr wrap="square" anchor="t">
+            <a:spAutoFit/>
+          </a:bodyPr>
+          <a:lstStyle/>
+          <a:p>
+            <a:pPr algn="l"/>
+            <a:r>
+              <a:rPr sz="1700" b="0">
+                <a:solidFill>
+                  <a:srgbClr val="121018"/>
+                </a:solidFill>
+                <a:latin typeface="DIN Next LT W23"/>
+                <a:ea typeface="DIN Next LT W23"/>
+                <a:cs typeface="DIN Next LT W23"/>
+              </a:rPr>
+              <a:t>Weight Decay (L2 regularization): adds a penalty to the loss proportional to the squared sum of weights to keep weights small and smooth.</a:t>
+            </a:r>
+          </a:p>
+        </p:txBody>
+      </p:sp>
+      <p:sp>
+        <p:nvSpPr>
+          <p:cNvPr id="12" name="TextBox 11"/>
+          <p:cNvSpPr txBox="1"/>
+          <p:nvPr/>
+        </p:nvSpPr>
+        <p:spPr>
+          <a:xfrm>
+            <a:off x="548640" y="3282696"/>
+            <a:ext cx="320040" cy="411480"/>
+          </a:xfrm>
+          <a:prstGeom prst="rect">
+            <a:avLst/>
+          </a:prstGeom>
+          <a:noFill/>
+        </p:spPr>
+        <p:txBody>
+          <a:bodyPr wrap="square" anchor="t">
+            <a:spAutoFit/>
+          </a:bodyPr>
+          <a:lstStyle/>
+          <a:p>
+            <a:pPr algn="l"/>
+            <a:r>
+              <a:rPr sz="1700" b="0">
+                <a:solidFill>
+                  <a:srgbClr val="9E59CD"/>
+                </a:solidFill>
+                <a:latin typeface="DIN Next LT W23"/>
+                <a:ea typeface="DIN Next LT W23"/>
+                <a:cs typeface="DIN Next LT W23"/>
+              </a:rPr>
+              <a:t>–</a:t>
+            </a:r>
+          </a:p>
+        </p:txBody>
+      </p:sp>
+      <p:sp>
+        <p:nvSpPr>
+          <p:cNvPr id="13" name="TextBox 12"/>
+          <p:cNvSpPr txBox="1"/>
+          <p:nvPr/>
+        </p:nvSpPr>
+        <p:spPr>
+          <a:xfrm>
+            <a:off x="914400" y="3282696"/>
+            <a:ext cx="9875519" cy="411480"/>
+          </a:xfrm>
+          <a:prstGeom prst="rect">
+            <a:avLst/>
+          </a:prstGeom>
+          <a:noFill/>
+        </p:spPr>
+        <p:txBody>
+          <a:bodyPr wrap="square" anchor="t">
+            <a:spAutoFit/>
+          </a:bodyPr>
+          <a:lstStyle/>
+          <a:p>
+            <a:pPr algn="l"/>
+            <a:r>
+              <a:rPr sz="1700" b="0">
+                <a:solidFill>
+                  <a:srgbClr val="121018"/>
+                </a:solidFill>
+                <a:latin typeface="DIN Next LT W23"/>
+                <a:ea typeface="DIN Next LT W23"/>
+                <a:cs typeface="DIN Next LT W23"/>
+              </a:rPr>
+              <a:t>Early stopping: monitor validation loss during training and stop when it ceases to improve for a certain number of epochs (patience).</a:t>
+            </a:r>
+          </a:p>
+        </p:txBody>
+      </p:sp>
+      <p:sp>
+        <p:nvSpPr>
+          <p:cNvPr id="14" name="Rectangle 13"/>
+          <p:cNvSpPr/>
+          <p:nvPr/>
+        </p:nvSpPr>
+        <p:spPr>
+          <a:xfrm>
+            <a:off x="548640" y="6446520"/>
+            <a:ext cx="11064240" cy="10972"/>
+          </a:xfrm>
+          <a:prstGeom prst="rect">
+            <a:avLst/>
+          </a:prstGeom>
+          <a:solidFill>
+            <a:srgbClr val="5234B7"/>
+          </a:solidFill>
+          <a:ln>
+            <a:noFill/>
+          </a:ln>
+          <a:effectLst/>
+        </p:spPr>
+        <p:style>
+          <a:lnRef idx="1">
+            <a:schemeClr val="accent1"/>
+          </a:lnRef>
+          <a:fillRef idx="3">
+            <a:schemeClr val="accent1"/>
+          </a:fillRef>
+          <a:effectRef idx="2">
+            <a:schemeClr val="accent1"/>
+          </a:effectRef>
+          <a:fontRef idx="minor">
+            <a:schemeClr val="lt1"/>
+          </a:fontRef>
+        </p:style>
+        <p:txBody>
+          <a:bodyPr rtlCol="0" anchor="ctr"/>
+          <a:lstStyle/>
+          <a:p>
+            <a:pPr algn="ctr"/>
+          </a:p>
+        </p:txBody>
+      </p:sp>
+      <p:sp>
+        <p:nvSpPr>
+          <p:cNvPr id="15" name="TextBox 14"/>
+          <p:cNvSpPr txBox="1"/>
+          <p:nvPr/>
+        </p:nvSpPr>
+        <p:spPr>
+          <a:xfrm>
+            <a:off x="548640" y="6510528"/>
+            <a:ext cx="2743200" cy="256032"/>
+          </a:xfrm>
+          <a:prstGeom prst="rect">
+            <a:avLst/>
+          </a:prstGeom>
+          <a:noFill/>
+        </p:spPr>
+        <p:txBody>
+          <a:bodyPr wrap="square" anchor="t">
+            <a:spAutoFit/>
+          </a:bodyPr>
+          <a:lstStyle/>
+          <a:p>
+            <a:pPr algn="l"/>
+            <a:r>
+              <a:rPr sz="1100" b="1">
+                <a:solidFill>
+                  <a:srgbClr val="5234B7"/>
+                </a:solidFill>
+                <a:latin typeface="DIN Next LT W23"/>
+                <a:ea typeface="DIN Next LT W23"/>
+                <a:cs typeface="DIN Next LT W23"/>
+              </a:rPr>
+              <a:t>ETRA</a:t>
+            </a:r>
+          </a:p>
+        </p:txBody>
+      </p:sp>
+      <p:sp>
+        <p:nvSpPr>
+          <p:cNvPr id="16" name="TextBox 15"/>
+          <p:cNvSpPr txBox="1"/>
+          <p:nvPr/>
+        </p:nvSpPr>
+        <p:spPr>
+          <a:xfrm>
+            <a:off x="9601200" y="6510528"/>
+            <a:ext cx="2011680" cy="256032"/>
+          </a:xfrm>
+          <a:prstGeom prst="rect">
+            <a:avLst/>
+          </a:prstGeom>
+          <a:noFill/>
+        </p:spPr>
+        <p:txBody>
+          <a:bodyPr wrap="square" anchor="t">
+            <a:spAutoFit/>
+          </a:bodyPr>
+          <a:lstStyle/>
+          <a:p>
+            <a:pPr algn="r"/>
+            <a:r>
+              <a:rPr sz="1100" b="0">
+                <a:solidFill>
+                  <a:srgbClr val="5A5470"/>
+                </a:solidFill>
+                <a:latin typeface="DIN Next LT W23"/>
+                <a:ea typeface="DIN Next LT W23"/>
+                <a:cs typeface="DIN Next LT W23"/>
+              </a:rPr>
+              <a:t>72  /  79</a:t>
+            </a:r>
+          </a:p>
+        </p:txBody>
+      </p:sp>
+    </p:spTree>
+  </p:cSld>
+  <p:clrMapOvr>
+    <a:masterClrMapping/>
+  </p:clrMapOvr>
+</p:sld>
+</file>
+
+<file path=ppt/slides/slide73.xml><?xml version="1.0" encoding="utf-8"?>
+<p:sld xmlns:a="http://schemas.openxmlformats.org/drawingml/2006/main" xmlns:p="http://schemas.openxmlformats.org/presentationml/2006/main" xmlns:r="http://schemas.openxmlformats.org/officeDocument/2006/relationships">
+  <p:cSld>
+    <p:bg>
+      <p:bgPr>
+        <a:solidFill>
+          <a:srgbClr val="FAF8FF"/>
+        </a:solidFill>
+        <a:effectLst/>
+      </p:bgPr>
+    </p:bg>
+    <p:spTree>
+      <p:nvGrpSpPr>
+        <p:cNvPr id="1" name=""/>
+        <p:cNvGrpSpPr/>
+        <p:nvPr/>
+      </p:nvGrpSpPr>
+      <p:grpSpPr/>
+      <p:sp>
+        <p:nvSpPr>
+          <p:cNvPr id="2" name="Rectangle 1"/>
+          <p:cNvSpPr/>
+          <p:nvPr/>
+        </p:nvSpPr>
+        <p:spPr>
+          <a:xfrm>
+            <a:off x="12136831" y="0"/>
+            <a:ext cx="54864" cy="6858000"/>
+          </a:xfrm>
+          <a:prstGeom prst="rect">
+            <a:avLst/>
+          </a:prstGeom>
+          <a:solidFill>
+            <a:srgbClr val="5234B7"/>
+          </a:solidFill>
+          <a:ln>
+            <a:noFill/>
+          </a:ln>
+          <a:effectLst/>
+        </p:spPr>
+        <p:style>
+          <a:lnRef idx="1">
+            <a:schemeClr val="accent1"/>
+          </a:lnRef>
+          <a:fillRef idx="3">
+            <a:schemeClr val="accent1"/>
+          </a:fillRef>
+          <a:effectRef idx="2">
+            <a:schemeClr val="accent1"/>
+          </a:effectRef>
+          <a:fontRef idx="minor">
+            <a:schemeClr val="lt1"/>
+          </a:fontRef>
+        </p:style>
+        <p:txBody>
+          <a:bodyPr rtlCol="0" anchor="ctr"/>
+          <a:lstStyle/>
+          <a:p>
+            <a:pPr algn="ctr"/>
+          </a:p>
+        </p:txBody>
+      </p:sp>
+      <p:pic>
+        <p:nvPicPr>
+          <p:cNvPr id="3" name="Picture 2" descr="etra-wordmark.png"/>
+          <p:cNvPicPr>
+            <a:picLocks noChangeAspect="1"/>
+          </p:cNvPicPr>
+          <p:nvPr/>
+        </p:nvPicPr>
+        <p:blipFill>
+          <a:blip r:embed="rId2"/>
+          <a:stretch>
+            <a:fillRect/>
+          </a:stretch>
+        </p:blipFill>
+        <p:spPr>
+          <a:xfrm>
+            <a:off x="10561320" y="411480"/>
+            <a:ext cx="1206201" cy="320040"/>
+          </a:xfrm>
+          <a:prstGeom prst="rect">
+            <a:avLst/>
+          </a:prstGeom>
+        </p:spPr>
+      </p:pic>
+      <p:sp>
+        <p:nvSpPr>
+          <p:cNvPr id="4" name="TextBox 3"/>
+          <p:cNvSpPr txBox="1"/>
+          <p:nvPr/>
+        </p:nvSpPr>
+        <p:spPr>
+          <a:xfrm>
+            <a:off x="548640" y="438912"/>
+            <a:ext cx="7772400" cy="274320"/>
+          </a:xfrm>
+          <a:prstGeom prst="rect">
+            <a:avLst/>
+          </a:prstGeom>
+          <a:noFill/>
+        </p:spPr>
+        <p:txBody>
+          <a:bodyPr wrap="square" anchor="t">
+            <a:spAutoFit/>
+          </a:bodyPr>
+          <a:lstStyle/>
+          <a:p>
+            <a:pPr algn="l"/>
+            <a:r>
+              <a:rPr sz="1200" b="0">
+                <a:solidFill>
+                  <a:srgbClr val="5A5470"/>
+                </a:solidFill>
+                <a:latin typeface="DIN Next LT W23"/>
+                <a:ea typeface="DIN Next LT W23"/>
+                <a:cs typeface="DIN Next LT W23"/>
+              </a:rPr>
+              <a:t>S07  ·  Deep Learning</a:t>
+            </a:r>
+          </a:p>
+        </p:txBody>
+      </p:sp>
+      <p:sp>
+        <p:nvSpPr>
+          <p:cNvPr id="5" name="Rectangle 4"/>
+          <p:cNvSpPr/>
+          <p:nvPr/>
+        </p:nvSpPr>
+        <p:spPr>
+          <a:xfrm>
+            <a:off x="548640" y="822960"/>
+            <a:ext cx="11064240" cy="10972"/>
+          </a:xfrm>
+          <a:prstGeom prst="rect">
+            <a:avLst/>
+          </a:prstGeom>
+          <a:solidFill>
+            <a:srgbClr val="E4DCF4"/>
+          </a:solidFill>
+          <a:ln>
+            <a:noFill/>
+          </a:ln>
+          <a:effectLst/>
+        </p:spPr>
+        <p:style>
+          <a:lnRef idx="1">
+            <a:schemeClr val="accent1"/>
+          </a:lnRef>
+          <a:fillRef idx="3">
+            <a:schemeClr val="accent1"/>
+          </a:fillRef>
+          <a:effectRef idx="2">
+            <a:schemeClr val="accent1"/>
+          </a:effectRef>
+          <a:fontRef idx="minor">
+            <a:schemeClr val="lt1"/>
+          </a:fontRef>
+        </p:style>
+        <p:txBody>
+          <a:bodyPr rtlCol="0" anchor="ctr"/>
+          <a:lstStyle/>
+          <a:p>
+            <a:pPr algn="ctr"/>
+          </a:p>
+        </p:txBody>
+      </p:sp>
+      <p:sp>
+        <p:nvSpPr>
+          <p:cNvPr id="6" name="TextBox 5"/>
+          <p:cNvSpPr txBox="1"/>
+          <p:nvPr/>
+        </p:nvSpPr>
+        <p:spPr>
+          <a:xfrm>
+            <a:off x="548640" y="1051560"/>
+            <a:ext cx="10241280" cy="594360"/>
+          </a:xfrm>
+          <a:prstGeom prst="rect">
+            <a:avLst/>
+          </a:prstGeom>
+          <a:noFill/>
+        </p:spPr>
+        <p:txBody>
+          <a:bodyPr wrap="square" anchor="t">
+            <a:spAutoFit/>
+          </a:bodyPr>
+          <a:lstStyle/>
+          <a:p>
+            <a:pPr algn="l"/>
+            <a:r>
+              <a:rPr sz="3200" b="1">
+                <a:solidFill>
+                  <a:srgbClr val="5234B7"/>
+                </a:solidFill>
+                <a:latin typeface="DIN Next LT W23"/>
+                <a:ea typeface="DIN Next LT W23"/>
+                <a:cs typeface="DIN Next LT W23"/>
+              </a:rPr>
+              <a:t>Regularization: Dropout, Weight Decay, and Early Stopping</a:t>
+            </a:r>
+          </a:p>
+        </p:txBody>
+      </p:sp>
+      <p:sp>
+        <p:nvSpPr>
+          <p:cNvPr id="7" name="TextBox 6"/>
+          <p:cNvSpPr txBox="1"/>
+          <p:nvPr/>
+        </p:nvSpPr>
+        <p:spPr>
+          <a:xfrm>
+            <a:off x="548640" y="1600200"/>
+            <a:ext cx="10241280" cy="365760"/>
+          </a:xfrm>
+          <a:prstGeom prst="rect">
+            <a:avLst/>
+          </a:prstGeom>
+          <a:noFill/>
+        </p:spPr>
+        <p:txBody>
+          <a:bodyPr wrap="square" anchor="t">
+            <a:spAutoFit/>
+          </a:bodyPr>
+          <a:lstStyle/>
+          <a:p>
+            <a:pPr algn="l"/>
+            <a:r>
+              <a:rPr sz="1500" b="0">
+                <a:solidFill>
+                  <a:srgbClr val="5A5470"/>
+                </a:solidFill>
+                <a:latin typeface="DIN Next LT W23"/>
+                <a:ea typeface="DIN Next LT W23"/>
+                <a:cs typeface="DIN Next LT W23"/>
+              </a:rPr>
+              <a:t>Constrain Capacity to Prevent Overfitting</a:t>
             </a:r>
           </a:p>
         </p:txBody>
@@ -47241,7 +47831,7 @@
                           </a:solidFill>
                           <a:latin typeface="Helvetica"/>
                         </a:rPr>
-                        <a:t>At inference</a:t>
+                        <a:t>Inference behavior</a:t>
                       </a:r>
                     </a:p>
                   </a:txBody>
@@ -47289,7 +47879,7 @@
                           </a:solidFill>
                           <a:latin typeface="Helvetica"/>
                         </a:rPr>
-                        <a:t>Randomly drop hidden units (p ≈ 0.2–0.5)</a:t>
+                        <a:t>Randomly drops connections</a:t>
                       </a:r>
                     </a:p>
                   </a:txBody>
@@ -47312,7 +47902,7 @@
                           </a:solidFill>
                           <a:latin typeface="Helvetica"/>
                         </a:rPr>
-                        <a:t>Off (weights scaled)</a:t>
+                        <a:t>Turned OFF (weights scaled)</a:t>
                       </a:r>
                     </a:p>
                   </a:txBody>
@@ -47337,7 +47927,7 @@
                           </a:solidFill>
                           <a:latin typeface="Helvetica"/>
                         </a:rPr>
-                        <a:t>L2 weight decay</a:t>
+                        <a:t>L2 Weight Decay</a:t>
                       </a:r>
                     </a:p>
                   </a:txBody>
@@ -47360,7 +47950,7 @@
                           </a:solidFill>
                           <a:latin typeface="Helvetica"/>
                         </a:rPr>
-                        <a:t>Shrink weights toward zero</a:t>
+                        <a:t>Shrinks weights toward zero</a:t>
                       </a:r>
                     </a:p>
                   </a:txBody>
@@ -47383,7 +47973,7 @@
                           </a:solidFill>
                           <a:latin typeface="Helvetica"/>
                         </a:rPr>
-                        <a:t>On (weights are static)</a:t>
+                        <a:t>Turned ON (weights are static)</a:t>
                       </a:r>
                     </a:p>
                   </a:txBody>
@@ -47408,7 +47998,7 @@
                           </a:solidFill>
                           <a:latin typeface="Helvetica"/>
                         </a:rPr>
-                        <a:t>Early stopping</a:t>
+                        <a:t>Early Stopping</a:t>
                       </a:r>
                     </a:p>
                   </a:txBody>
@@ -47431,7 +48021,7 @@
                           </a:solidFill>
                           <a:latin typeface="Helvetica"/>
                         </a:rPr>
-                        <a:t>Stop at lowest validation loss</a:t>
+                        <a:t>Halts training at lowest val loss</a:t>
                       </a:r>
                     </a:p>
                   </a:txBody>
@@ -47454,7 +48044,7 @@
                           </a:solidFill>
                           <a:latin typeface="Helvetica"/>
                         </a:rPr>
-                        <a:t>N/A — checkpoint the best</a:t>
+                        <a:t>N/A (model is checkpointed)</a:t>
                       </a:r>
                     </a:p>
                   </a:txBody>
@@ -47471,90 +48061,7 @@
       </p:graphicFrame>
       <p:sp>
         <p:nvSpPr>
-          <p:cNvPr id="9" name="Rounded Rectangle 8"/>
-          <p:cNvSpPr/>
-          <p:nvPr/>
-        </p:nvSpPr>
-        <p:spPr>
-          <a:xfrm>
-            <a:off x="548640" y="4032504"/>
-            <a:ext cx="10972800" cy="411480"/>
-          </a:xfrm>
-          <a:prstGeom prst="roundRect">
-            <a:avLst>
-              <a:gd name="adj" fmla="val 10000"/>
-            </a:avLst>
-          </a:prstGeom>
-          <a:solidFill>
-            <a:srgbClr val="EEE8FA"/>
-          </a:solidFill>
-          <a:ln>
-            <a:noFill/>
-          </a:ln>
-          <a:effectLst/>
-        </p:spPr>
-        <p:style>
-          <a:lnRef idx="1">
-            <a:schemeClr val="accent1"/>
-          </a:lnRef>
-          <a:fillRef idx="3">
-            <a:schemeClr val="accent1"/>
-          </a:fillRef>
-          <a:effectRef idx="2">
-            <a:schemeClr val="accent1"/>
-          </a:effectRef>
-          <a:fontRef idx="minor">
-            <a:schemeClr val="lt1"/>
-          </a:fontRef>
-        </p:style>
-        <p:txBody>
-          <a:bodyPr rtlCol="0" anchor="ctr"/>
-          <a:lstStyle/>
-          <a:p>
-            <a:pPr algn="ctr"/>
-          </a:p>
-        </p:txBody>
-      </p:sp>
-      <p:sp>
-        <p:nvSpPr>
-          <p:cNvPr id="10" name="TextBox 9"/>
-          <p:cNvSpPr txBox="1"/>
-          <p:nvPr/>
-        </p:nvSpPr>
-        <p:spPr>
-          <a:xfrm>
-            <a:off x="868680" y="4105656"/>
-            <a:ext cx="10332720" cy="292608"/>
-          </a:xfrm>
-          <a:prstGeom prst="rect">
-            <a:avLst/>
-          </a:prstGeom>
-          <a:noFill/>
-        </p:spPr>
-        <p:txBody>
-          <a:bodyPr wrap="square" anchor="t">
-            <a:spAutoFit/>
-          </a:bodyPr>
-          <a:lstStyle/>
-          <a:p>
-            <a:pPr algn="l"/>
-            <a:r>
-              <a:rPr sz="1200" b="0">
-                <a:solidFill>
-                  <a:srgbClr val="5A5470"/>
-                </a:solidFill>
-                <a:latin typeface="DIN Next LT W23"/>
-                <a:ea typeface="DIN Next LT W23"/>
-                <a:cs typeface="DIN Next LT W23"/>
-              </a:rPr>
-              <a:t>Dropout is an implicit ensemble. Weight decay is a smoothness prior. Early stopping is free.</a:t>
-            </a:r>
-          </a:p>
-        </p:txBody>
-      </p:sp>
-      <p:sp>
-        <p:nvSpPr>
-          <p:cNvPr id="11" name="Rectangle 10"/>
+          <p:cNvPr id="9" name="Rectangle 8"/>
           <p:cNvSpPr/>
           <p:nvPr/>
         </p:nvSpPr>
@@ -47598,7 +48105,7 @@
       </p:sp>
       <p:sp>
         <p:nvSpPr>
-          <p:cNvPr id="12" name="TextBox 11"/>
+          <p:cNvPr id="10" name="TextBox 9"/>
           <p:cNvSpPr txBox="1"/>
           <p:nvPr/>
         </p:nvSpPr>
@@ -47635,7 +48142,7 @@
       </p:sp>
       <p:sp>
         <p:nvSpPr>
-          <p:cNvPr id="13" name="TextBox 12"/>
+          <p:cNvPr id="11" name="TextBox 10"/>
           <p:cNvSpPr txBox="1"/>
           <p:nvPr/>
         </p:nvSpPr>
@@ -47665,749 +48172,7 @@
                 <a:ea typeface="DIN Next LT W23"/>
                 <a:cs typeface="DIN Next LT W23"/>
               </a:rPr>
-              <a:t>72  /  78</a:t>
-            </a:r>
-          </a:p>
-        </p:txBody>
-      </p:sp>
-    </p:spTree>
-  </p:cSld>
-  <p:clrMapOvr>
-    <a:masterClrMapping/>
-  </p:clrMapOvr>
-</p:sld>
-</file>
-
-<file path=ppt/slides/slide73.xml><?xml version="1.0" encoding="utf-8"?>
-<p:sld xmlns:a="http://schemas.openxmlformats.org/drawingml/2006/main" xmlns:p="http://schemas.openxmlformats.org/presentationml/2006/main" xmlns:r="http://schemas.openxmlformats.org/officeDocument/2006/relationships">
-  <p:cSld>
-    <p:bg>
-      <p:bgPr>
-        <a:solidFill>
-          <a:srgbClr val="FAF8FF"/>
-        </a:solidFill>
-        <a:effectLst/>
-      </p:bgPr>
-    </p:bg>
-    <p:spTree>
-      <p:nvGrpSpPr>
-        <p:cNvPr id="1" name=""/>
-        <p:cNvGrpSpPr/>
-        <p:nvPr/>
-      </p:nvGrpSpPr>
-      <p:grpSpPr/>
-      <p:sp>
-        <p:nvSpPr>
-          <p:cNvPr id="2" name="Rectangle 1"/>
-          <p:cNvSpPr/>
-          <p:nvPr/>
-        </p:nvSpPr>
-        <p:spPr>
-          <a:xfrm>
-            <a:off x="12136831" y="0"/>
-            <a:ext cx="54864" cy="6858000"/>
-          </a:xfrm>
-          <a:prstGeom prst="rect">
-            <a:avLst/>
-          </a:prstGeom>
-          <a:solidFill>
-            <a:srgbClr val="5234B7"/>
-          </a:solidFill>
-          <a:ln>
-            <a:noFill/>
-          </a:ln>
-          <a:effectLst/>
-        </p:spPr>
-        <p:style>
-          <a:lnRef idx="1">
-            <a:schemeClr val="accent1"/>
-          </a:lnRef>
-          <a:fillRef idx="3">
-            <a:schemeClr val="accent1"/>
-          </a:fillRef>
-          <a:effectRef idx="2">
-            <a:schemeClr val="accent1"/>
-          </a:effectRef>
-          <a:fontRef idx="minor">
-            <a:schemeClr val="lt1"/>
-          </a:fontRef>
-        </p:style>
-        <p:txBody>
-          <a:bodyPr rtlCol="0" anchor="ctr"/>
-          <a:lstStyle/>
-          <a:p>
-            <a:pPr algn="ctr"/>
-          </a:p>
-        </p:txBody>
-      </p:sp>
-      <p:pic>
-        <p:nvPicPr>
-          <p:cNvPr id="3" name="Picture 2" descr="etra-wordmark.png"/>
-          <p:cNvPicPr>
-            <a:picLocks noChangeAspect="1"/>
-          </p:cNvPicPr>
-          <p:nvPr/>
-        </p:nvPicPr>
-        <p:blipFill>
-          <a:blip r:embed="rId2"/>
-          <a:stretch>
-            <a:fillRect/>
-          </a:stretch>
-        </p:blipFill>
-        <p:spPr>
-          <a:xfrm>
-            <a:off x="10561320" y="411480"/>
-            <a:ext cx="1206201" cy="320040"/>
-          </a:xfrm>
-          <a:prstGeom prst="rect">
-            <a:avLst/>
-          </a:prstGeom>
-        </p:spPr>
-      </p:pic>
-      <p:sp>
-        <p:nvSpPr>
-          <p:cNvPr id="4" name="TextBox 3"/>
-          <p:cNvSpPr txBox="1"/>
-          <p:nvPr/>
-        </p:nvSpPr>
-        <p:spPr>
-          <a:xfrm>
-            <a:off x="548640" y="438912"/>
-            <a:ext cx="7772400" cy="274320"/>
-          </a:xfrm>
-          <a:prstGeom prst="rect">
-            <a:avLst/>
-          </a:prstGeom>
-          <a:noFill/>
-        </p:spPr>
-        <p:txBody>
-          <a:bodyPr wrap="square" anchor="t">
-            <a:spAutoFit/>
-          </a:bodyPr>
-          <a:lstStyle/>
-          <a:p>
-            <a:pPr algn="l"/>
-            <a:r>
-              <a:rPr sz="1200" b="0">
-                <a:solidFill>
-                  <a:srgbClr val="5A5470"/>
-                </a:solidFill>
-                <a:latin typeface="DIN Next LT W23"/>
-                <a:ea typeface="DIN Next LT W23"/>
-                <a:cs typeface="DIN Next LT W23"/>
-              </a:rPr>
-              <a:t>S07  ·  Deep Learning</a:t>
-            </a:r>
-          </a:p>
-        </p:txBody>
-      </p:sp>
-      <p:sp>
-        <p:nvSpPr>
-          <p:cNvPr id="5" name="Rectangle 4"/>
-          <p:cNvSpPr/>
-          <p:nvPr/>
-        </p:nvSpPr>
-        <p:spPr>
-          <a:xfrm>
-            <a:off x="548640" y="822960"/>
-            <a:ext cx="11064240" cy="10972"/>
-          </a:xfrm>
-          <a:prstGeom prst="rect">
-            <a:avLst/>
-          </a:prstGeom>
-          <a:solidFill>
-            <a:srgbClr val="E4DCF4"/>
-          </a:solidFill>
-          <a:ln>
-            <a:noFill/>
-          </a:ln>
-          <a:effectLst/>
-        </p:spPr>
-        <p:style>
-          <a:lnRef idx="1">
-            <a:schemeClr val="accent1"/>
-          </a:lnRef>
-          <a:fillRef idx="3">
-            <a:schemeClr val="accent1"/>
-          </a:fillRef>
-          <a:effectRef idx="2">
-            <a:schemeClr val="accent1"/>
-          </a:effectRef>
-          <a:fontRef idx="minor">
-            <a:schemeClr val="lt1"/>
-          </a:fontRef>
-        </p:style>
-        <p:txBody>
-          <a:bodyPr rtlCol="0" anchor="ctr"/>
-          <a:lstStyle/>
-          <a:p>
-            <a:pPr algn="ctr"/>
-          </a:p>
-        </p:txBody>
-      </p:sp>
-      <p:sp>
-        <p:nvSpPr>
-          <p:cNvPr id="6" name="TextBox 5"/>
-          <p:cNvSpPr txBox="1"/>
-          <p:nvPr/>
-        </p:nvSpPr>
-        <p:spPr>
-          <a:xfrm>
-            <a:off x="548640" y="1051560"/>
-            <a:ext cx="10241280" cy="594360"/>
-          </a:xfrm>
-          <a:prstGeom prst="rect">
-            <a:avLst/>
-          </a:prstGeom>
-          <a:noFill/>
-        </p:spPr>
-        <p:txBody>
-          <a:bodyPr wrap="square" anchor="t">
-            <a:spAutoFit/>
-          </a:bodyPr>
-          <a:lstStyle/>
-          <a:p>
-            <a:pPr algn="l"/>
-            <a:r>
-              <a:rPr sz="3200" b="1">
-                <a:solidFill>
-                  <a:srgbClr val="5234B7"/>
-                </a:solidFill>
-                <a:latin typeface="DIN Next LT W23"/>
-                <a:ea typeface="DIN Next LT W23"/>
-                <a:cs typeface="DIN Next LT W23"/>
-              </a:rPr>
-              <a:t>Sequential Data &amp; Vanilla RNNs</a:t>
-            </a:r>
-          </a:p>
-        </p:txBody>
-      </p:sp>
-      <p:sp>
-        <p:nvSpPr>
-          <p:cNvPr id="7" name="TextBox 6"/>
-          <p:cNvSpPr txBox="1"/>
-          <p:nvPr/>
-        </p:nvSpPr>
-        <p:spPr>
-          <a:xfrm>
-            <a:off x="548640" y="1600200"/>
-            <a:ext cx="10241280" cy="365760"/>
-          </a:xfrm>
-          <a:prstGeom prst="rect">
-            <a:avLst/>
-          </a:prstGeom>
-          <a:noFill/>
-        </p:spPr>
-        <p:txBody>
-          <a:bodyPr wrap="square" anchor="t">
-            <a:spAutoFit/>
-          </a:bodyPr>
-          <a:lstStyle/>
-          <a:p>
-            <a:pPr algn="l"/>
-            <a:r>
-              <a:rPr sz="1500" b="0">
-                <a:solidFill>
-                  <a:srgbClr val="5A5470"/>
-                </a:solidFill>
-                <a:latin typeface="DIN Next LT W23"/>
-                <a:ea typeface="DIN Next LT W23"/>
-                <a:cs typeface="DIN Next LT W23"/>
-              </a:rPr>
-              <a:t>One Transition, Unfolded Through Time</a:t>
-            </a:r>
-          </a:p>
-        </p:txBody>
-      </p:sp>
-      <p:sp>
-        <p:nvSpPr>
-          <p:cNvPr id="8" name="Rounded Rectangle 7"/>
-          <p:cNvSpPr/>
-          <p:nvPr/>
-        </p:nvSpPr>
-        <p:spPr>
-          <a:xfrm>
-            <a:off x="548640" y="1965960"/>
-            <a:ext cx="10972800" cy="640080"/>
-          </a:xfrm>
-          <a:prstGeom prst="roundRect">
-            <a:avLst>
-              <a:gd name="adj" fmla="val 10000"/>
-            </a:avLst>
-          </a:prstGeom>
-          <a:solidFill>
-            <a:srgbClr val="EEE8FA"/>
-          </a:solidFill>
-          <a:ln>
-            <a:noFill/>
-          </a:ln>
-          <a:effectLst/>
-        </p:spPr>
-        <p:style>
-          <a:lnRef idx="1">
-            <a:schemeClr val="accent1"/>
-          </a:lnRef>
-          <a:fillRef idx="3">
-            <a:schemeClr val="accent1"/>
-          </a:fillRef>
-          <a:effectRef idx="2">
-            <a:schemeClr val="accent1"/>
-          </a:effectRef>
-          <a:fontRef idx="minor">
-            <a:schemeClr val="lt1"/>
-          </a:fontRef>
-        </p:style>
-        <p:txBody>
-          <a:bodyPr rtlCol="0" anchor="ctr"/>
-          <a:lstStyle/>
-          <a:p>
-            <a:pPr algn="ctr"/>
-          </a:p>
-        </p:txBody>
-      </p:sp>
-      <p:sp>
-        <p:nvSpPr>
-          <p:cNvPr id="9" name="TextBox 8"/>
-          <p:cNvSpPr txBox="1"/>
-          <p:nvPr/>
-        </p:nvSpPr>
-        <p:spPr>
-          <a:xfrm>
-            <a:off x="868680" y="2084831"/>
-            <a:ext cx="10332720" cy="411480"/>
-          </a:xfrm>
-          <a:prstGeom prst="rect">
-            <a:avLst/>
-          </a:prstGeom>
-          <a:noFill/>
-        </p:spPr>
-        <p:txBody>
-          <a:bodyPr wrap="square" anchor="t">
-            <a:spAutoFit/>
-          </a:bodyPr>
-          <a:lstStyle/>
-          <a:p>
-            <a:pPr algn="l"/>
-            <a:r>
-              <a:rPr sz="1400" b="0">
-                <a:solidFill>
-                  <a:srgbClr val="121018"/>
-                </a:solidFill>
-                <a:latin typeface="DIN Next LT W23"/>
-                <a:ea typeface="DIN Next LT W23"/>
-                <a:cs typeface="DIN Next LT W23"/>
-              </a:rPr>
-              <a:t>Text, audio, and sensors have order. Shuffling them destroys meaning.</a:t>
-            </a:r>
-          </a:p>
-        </p:txBody>
-      </p:sp>
-      <p:sp>
-        <p:nvSpPr>
-          <p:cNvPr id="10" name="Rounded Rectangle 9"/>
-          <p:cNvSpPr/>
-          <p:nvPr/>
-        </p:nvSpPr>
-        <p:spPr>
-          <a:xfrm>
-            <a:off x="548640" y="2743200"/>
-            <a:ext cx="10972800" cy="1417320"/>
-          </a:xfrm>
-          <a:prstGeom prst="roundRect">
-            <a:avLst>
-              <a:gd name="adj" fmla="val 10000"/>
-            </a:avLst>
-          </a:prstGeom>
-          <a:solidFill>
-            <a:srgbClr val="EEE8FA"/>
-          </a:solidFill>
-          <a:ln>
-            <a:noFill/>
-          </a:ln>
-          <a:effectLst/>
-        </p:spPr>
-        <p:style>
-          <a:lnRef idx="1">
-            <a:schemeClr val="accent1"/>
-          </a:lnRef>
-          <a:fillRef idx="3">
-            <a:schemeClr val="accent1"/>
-          </a:fillRef>
-          <a:effectRef idx="2">
-            <a:schemeClr val="accent1"/>
-          </a:effectRef>
-          <a:fontRef idx="minor">
-            <a:schemeClr val="lt1"/>
-          </a:fontRef>
-        </p:style>
-        <p:txBody>
-          <a:bodyPr rtlCol="0" anchor="ctr"/>
-          <a:lstStyle/>
-          <a:p>
-            <a:pPr algn="ctr"/>
-          </a:p>
-        </p:txBody>
-      </p:sp>
-      <p:pic>
-        <p:nvPicPr>
-          <p:cNvPr id="11" name="Picture 10" descr="f-2d62af7528050520.png"/>
-          <p:cNvPicPr>
-            <a:picLocks noChangeAspect="1"/>
-          </p:cNvPicPr>
-          <p:nvPr/>
-        </p:nvPicPr>
-        <p:blipFill>
-          <a:blip r:embed="rId3"/>
-          <a:stretch>
-            <a:fillRect/>
-          </a:stretch>
-        </p:blipFill>
-        <p:spPr>
-          <a:xfrm>
-            <a:off x="2529632" y="2852928"/>
-            <a:ext cx="7010814" cy="868680"/>
-          </a:xfrm>
-          <a:prstGeom prst="rect">
-            <a:avLst/>
-          </a:prstGeom>
-        </p:spPr>
-      </p:pic>
-      <p:sp>
-        <p:nvSpPr>
-          <p:cNvPr id="12" name="TextBox 11"/>
-          <p:cNvSpPr txBox="1"/>
-          <p:nvPr/>
-        </p:nvSpPr>
-        <p:spPr>
-          <a:xfrm>
-            <a:off x="914400" y="3840480"/>
-            <a:ext cx="10241280" cy="256032"/>
-          </a:xfrm>
-          <a:prstGeom prst="rect">
-            <a:avLst/>
-          </a:prstGeom>
-          <a:noFill/>
-        </p:spPr>
-        <p:txBody>
-          <a:bodyPr wrap="square" anchor="t">
-            <a:spAutoFit/>
-          </a:bodyPr>
-          <a:lstStyle/>
-          <a:p>
-            <a:pPr algn="ctr"/>
-            <a:r>
-              <a:rPr sz="1200" b="0">
-                <a:solidFill>
-                  <a:srgbClr val="5A5470"/>
-                </a:solidFill>
-                <a:latin typeface="DIN Next LT W23"/>
-                <a:ea typeface="DIN Next LT W23"/>
-                <a:cs typeface="DIN Next LT W23"/>
-              </a:rPr>
-              <a:t>Same weights at every timestep  ·  hₜ is a running memory of the past</a:t>
-            </a:r>
-          </a:p>
-        </p:txBody>
-      </p:sp>
-      <p:sp>
-        <p:nvSpPr>
-          <p:cNvPr id="13" name="TextBox 12"/>
-          <p:cNvSpPr txBox="1"/>
-          <p:nvPr/>
-        </p:nvSpPr>
-        <p:spPr>
-          <a:xfrm>
-            <a:off x="548640" y="4270248"/>
-            <a:ext cx="320040" cy="384048"/>
-          </a:xfrm>
-          <a:prstGeom prst="rect">
-            <a:avLst/>
-          </a:prstGeom>
-          <a:noFill/>
-        </p:spPr>
-        <p:txBody>
-          <a:bodyPr wrap="square" anchor="t">
-            <a:spAutoFit/>
-          </a:bodyPr>
-          <a:lstStyle/>
-          <a:p>
-            <a:pPr algn="l"/>
-            <a:r>
-              <a:rPr sz="1300" b="0">
-                <a:solidFill>
-                  <a:srgbClr val="9E59CD"/>
-                </a:solidFill>
-                <a:latin typeface="DIN Next LT W23"/>
-                <a:ea typeface="DIN Next LT W23"/>
-                <a:cs typeface="DIN Next LT W23"/>
-              </a:rPr>
-              <a:t>–</a:t>
-            </a:r>
-          </a:p>
-        </p:txBody>
-      </p:sp>
-      <p:sp>
-        <p:nvSpPr>
-          <p:cNvPr id="14" name="TextBox 13"/>
-          <p:cNvSpPr txBox="1"/>
-          <p:nvPr/>
-        </p:nvSpPr>
-        <p:spPr>
-          <a:xfrm>
-            <a:off x="914400" y="4270248"/>
-            <a:ext cx="9875519" cy="384048"/>
-          </a:xfrm>
-          <a:prstGeom prst="rect">
-            <a:avLst/>
-          </a:prstGeom>
-          <a:noFill/>
-        </p:spPr>
-        <p:txBody>
-          <a:bodyPr wrap="square" anchor="t">
-            <a:spAutoFit/>
-          </a:bodyPr>
-          <a:lstStyle/>
-          <a:p>
-            <a:pPr algn="l"/>
-            <a:r>
-              <a:rPr sz="1300" b="0">
-                <a:solidFill>
-                  <a:srgbClr val="121018"/>
-                </a:solidFill>
-                <a:latin typeface="DIN Next LT W23"/>
-                <a:ea typeface="DIN Next LT W23"/>
-                <a:cs typeface="DIN Next LT W23"/>
-              </a:rPr>
-              <a:t>Parameter sharing across time is efficient — but long sequences multiply Jacobians.</a:t>
-            </a:r>
-          </a:p>
-        </p:txBody>
-      </p:sp>
-      <p:sp>
-        <p:nvSpPr>
-          <p:cNvPr id="15" name="TextBox 14"/>
-          <p:cNvSpPr txBox="1"/>
-          <p:nvPr/>
-        </p:nvSpPr>
-        <p:spPr>
-          <a:xfrm>
-            <a:off x="548640" y="4690872"/>
-            <a:ext cx="320040" cy="384048"/>
-          </a:xfrm>
-          <a:prstGeom prst="rect">
-            <a:avLst/>
-          </a:prstGeom>
-          <a:noFill/>
-        </p:spPr>
-        <p:txBody>
-          <a:bodyPr wrap="square" anchor="t">
-            <a:spAutoFit/>
-          </a:bodyPr>
-          <a:lstStyle/>
-          <a:p>
-            <a:pPr algn="l"/>
-            <a:r>
-              <a:rPr sz="1300" b="0">
-                <a:solidFill>
-                  <a:srgbClr val="9E59CD"/>
-                </a:solidFill>
-                <a:latin typeface="DIN Next LT W23"/>
-                <a:ea typeface="DIN Next LT W23"/>
-                <a:cs typeface="DIN Next LT W23"/>
-              </a:rPr>
-              <a:t>–</a:t>
-            </a:r>
-          </a:p>
-        </p:txBody>
-      </p:sp>
-      <p:sp>
-        <p:nvSpPr>
-          <p:cNvPr id="16" name="TextBox 15"/>
-          <p:cNvSpPr txBox="1"/>
-          <p:nvPr/>
-        </p:nvSpPr>
-        <p:spPr>
-          <a:xfrm>
-            <a:off x="914400" y="4690872"/>
-            <a:ext cx="9875519" cy="384048"/>
-          </a:xfrm>
-          <a:prstGeom prst="rect">
-            <a:avLst/>
-          </a:prstGeom>
-          <a:noFill/>
-        </p:spPr>
-        <p:txBody>
-          <a:bodyPr wrap="square" anchor="t">
-            <a:spAutoFit/>
-          </a:bodyPr>
-          <a:lstStyle/>
-          <a:p>
-            <a:pPr algn="l"/>
-            <a:r>
-              <a:rPr sz="1300" b="0">
-                <a:solidFill>
-                  <a:srgbClr val="121018"/>
-                </a:solidFill>
-                <a:latin typeface="DIN Next LT W23"/>
-                <a:ea typeface="DIN Next LT W23"/>
-                <a:cs typeface="DIN Next LT W23"/>
-              </a:rPr>
-              <a:t>Vanilla RNNs struggle with long-range dependencies (vanishing / exploding gradients).</a:t>
-            </a:r>
-          </a:p>
-        </p:txBody>
-      </p:sp>
-      <p:sp>
-        <p:nvSpPr>
-          <p:cNvPr id="17" name="TextBox 16"/>
-          <p:cNvSpPr txBox="1"/>
-          <p:nvPr/>
-        </p:nvSpPr>
-        <p:spPr>
-          <a:xfrm>
-            <a:off x="548640" y="5989320"/>
-            <a:ext cx="10972800" cy="228600"/>
-          </a:xfrm>
-          <a:prstGeom prst="rect">
-            <a:avLst/>
-          </a:prstGeom>
-          <a:noFill/>
-        </p:spPr>
-        <p:txBody>
-          <a:bodyPr wrap="square" anchor="t">
-            <a:spAutoFit/>
-          </a:bodyPr>
-          <a:lstStyle/>
-          <a:p>
-            <a:pPr algn="l"/>
-            <a:r>
-              <a:rPr sz="1200" b="0">
-                <a:solidFill>
-                  <a:srgbClr val="5A5470"/>
-                </a:solidFill>
-                <a:latin typeface="DIN Next LT W23"/>
-                <a:ea typeface="DIN Next LT W23"/>
-                <a:cs typeface="DIN Next LT W23"/>
-              </a:rPr>
-              <a:t>Backprop through 50 steps ≈ multiplying a matrix 50 times.</a:t>
-            </a:r>
-          </a:p>
-        </p:txBody>
-      </p:sp>
-      <p:sp>
-        <p:nvSpPr>
-          <p:cNvPr id="18" name="Rectangle 17"/>
-          <p:cNvSpPr/>
-          <p:nvPr/>
-        </p:nvSpPr>
-        <p:spPr>
-          <a:xfrm>
-            <a:off x="548640" y="6446520"/>
-            <a:ext cx="11064240" cy="10972"/>
-          </a:xfrm>
-          <a:prstGeom prst="rect">
-            <a:avLst/>
-          </a:prstGeom>
-          <a:solidFill>
-            <a:srgbClr val="5234B7"/>
-          </a:solidFill>
-          <a:ln>
-            <a:noFill/>
-          </a:ln>
-          <a:effectLst/>
-        </p:spPr>
-        <p:style>
-          <a:lnRef idx="1">
-            <a:schemeClr val="accent1"/>
-          </a:lnRef>
-          <a:fillRef idx="3">
-            <a:schemeClr val="accent1"/>
-          </a:fillRef>
-          <a:effectRef idx="2">
-            <a:schemeClr val="accent1"/>
-          </a:effectRef>
-          <a:fontRef idx="minor">
-            <a:schemeClr val="lt1"/>
-          </a:fontRef>
-        </p:style>
-        <p:txBody>
-          <a:bodyPr rtlCol="0" anchor="ctr"/>
-          <a:lstStyle/>
-          <a:p>
-            <a:pPr algn="ctr"/>
-          </a:p>
-        </p:txBody>
-      </p:sp>
-      <p:sp>
-        <p:nvSpPr>
-          <p:cNvPr id="19" name="TextBox 18"/>
-          <p:cNvSpPr txBox="1"/>
-          <p:nvPr/>
-        </p:nvSpPr>
-        <p:spPr>
-          <a:xfrm>
-            <a:off x="548640" y="6510528"/>
-            <a:ext cx="2743200" cy="256032"/>
-          </a:xfrm>
-          <a:prstGeom prst="rect">
-            <a:avLst/>
-          </a:prstGeom>
-          <a:noFill/>
-        </p:spPr>
-        <p:txBody>
-          <a:bodyPr wrap="square" anchor="t">
-            <a:spAutoFit/>
-          </a:bodyPr>
-          <a:lstStyle/>
-          <a:p>
-            <a:pPr algn="l"/>
-            <a:r>
-              <a:rPr sz="1100" b="1">
-                <a:solidFill>
-                  <a:srgbClr val="5234B7"/>
-                </a:solidFill>
-                <a:latin typeface="DIN Next LT W23"/>
-                <a:ea typeface="DIN Next LT W23"/>
-                <a:cs typeface="DIN Next LT W23"/>
-              </a:rPr>
-              <a:t>ETRA</a:t>
-            </a:r>
-          </a:p>
-        </p:txBody>
-      </p:sp>
-      <p:sp>
-        <p:nvSpPr>
-          <p:cNvPr id="20" name="TextBox 19"/>
-          <p:cNvSpPr txBox="1"/>
-          <p:nvPr/>
-        </p:nvSpPr>
-        <p:spPr>
-          <a:xfrm>
-            <a:off x="9601200" y="6510528"/>
-            <a:ext cx="2011680" cy="256032"/>
-          </a:xfrm>
-          <a:prstGeom prst="rect">
-            <a:avLst/>
-          </a:prstGeom>
-          <a:noFill/>
-        </p:spPr>
-        <p:txBody>
-          <a:bodyPr wrap="square" anchor="t">
-            <a:spAutoFit/>
-          </a:bodyPr>
-          <a:lstStyle/>
-          <a:p>
-            <a:pPr algn="r"/>
-            <a:r>
-              <a:rPr sz="1100" b="0">
-                <a:solidFill>
-                  <a:srgbClr val="5A5470"/>
-                </a:solidFill>
-                <a:latin typeface="DIN Next LT W23"/>
-                <a:ea typeface="DIN Next LT W23"/>
-                <a:cs typeface="DIN Next LT W23"/>
-              </a:rPr>
-              <a:t>73  /  78</a:t>
+              <a:t>73  /  79</a:t>
             </a:r>
           </a:p>
         </p:txBody>
@@ -48619,7 +48384,7 @@
                 <a:ea typeface="DIN Next LT W23"/>
                 <a:cs typeface="DIN Next LT W23"/>
               </a:rPr>
-              <a:t>RNN Unfolded Through Time</a:t>
+              <a:t>Sequential Data &amp; Vanilla RNNs</a:t>
             </a:r>
           </a:p>
         </p:txBody>
@@ -48656,7 +48421,7 @@
                 <a:ea typeface="DIN Next LT W23"/>
                 <a:cs typeface="DIN Next LT W23"/>
               </a:rPr>
-              <a:t>Rolled Cell = Shared Weights Across Steps</a:t>
+              <a:t>One Transition, Unfolded Through Time</a:t>
             </a:r>
           </a:p>
         </p:txBody>
@@ -48670,7 +48435,7 @@
         <p:spPr>
           <a:xfrm>
             <a:off x="548640" y="1965960"/>
-            <a:ext cx="10972800" cy="3977639"/>
+            <a:ext cx="10972800" cy="640080"/>
           </a:xfrm>
           <a:prstGeom prst="roundRect">
             <a:avLst>
@@ -48707,9 +48472,92 @@
           </a:p>
         </p:txBody>
       </p:sp>
+      <p:sp>
+        <p:nvSpPr>
+          <p:cNvPr id="9" name="TextBox 8"/>
+          <p:cNvSpPr txBox="1"/>
+          <p:nvPr/>
+        </p:nvSpPr>
+        <p:spPr>
+          <a:xfrm>
+            <a:off x="868680" y="2084831"/>
+            <a:ext cx="10332720" cy="411480"/>
+          </a:xfrm>
+          <a:prstGeom prst="rect">
+            <a:avLst/>
+          </a:prstGeom>
+          <a:noFill/>
+        </p:spPr>
+        <p:txBody>
+          <a:bodyPr wrap="square" anchor="t">
+            <a:spAutoFit/>
+          </a:bodyPr>
+          <a:lstStyle/>
+          <a:p>
+            <a:pPr algn="l"/>
+            <a:r>
+              <a:rPr sz="1400" b="0">
+                <a:solidFill>
+                  <a:srgbClr val="121018"/>
+                </a:solidFill>
+                <a:latin typeface="DIN Next LT W23"/>
+                <a:ea typeface="DIN Next LT W23"/>
+                <a:cs typeface="DIN Next LT W23"/>
+              </a:rPr>
+              <a:t>Text, audio, and sensors have order. Shuffling them destroys meaning.</a:t>
+            </a:r>
+          </a:p>
+        </p:txBody>
+      </p:sp>
+      <p:sp>
+        <p:nvSpPr>
+          <p:cNvPr id="10" name="Rounded Rectangle 9"/>
+          <p:cNvSpPr/>
+          <p:nvPr/>
+        </p:nvSpPr>
+        <p:spPr>
+          <a:xfrm>
+            <a:off x="548640" y="2743200"/>
+            <a:ext cx="10972800" cy="1417320"/>
+          </a:xfrm>
+          <a:prstGeom prst="roundRect">
+            <a:avLst>
+              <a:gd name="adj" fmla="val 10000"/>
+            </a:avLst>
+          </a:prstGeom>
+          <a:solidFill>
+            <a:srgbClr val="EEE8FA"/>
+          </a:solidFill>
+          <a:ln>
+            <a:noFill/>
+          </a:ln>
+          <a:effectLst/>
+        </p:spPr>
+        <p:style>
+          <a:lnRef idx="1">
+            <a:schemeClr val="accent1"/>
+          </a:lnRef>
+          <a:fillRef idx="3">
+            <a:schemeClr val="accent1"/>
+          </a:fillRef>
+          <a:effectRef idx="2">
+            <a:schemeClr val="accent1"/>
+          </a:effectRef>
+          <a:fontRef idx="minor">
+            <a:schemeClr val="lt1"/>
+          </a:fontRef>
+        </p:style>
+        <p:txBody>
+          <a:bodyPr rtlCol="0" anchor="ctr"/>
+          <a:lstStyle/>
+          <a:p>
+            <a:pPr algn="ctr"/>
+          </a:p>
+        </p:txBody>
+      </p:sp>
       <p:pic>
         <p:nvPicPr>
-          <p:cNvPr id="9" name="Picture 8" descr="rnn-unfold.png"/>
+          <p:cNvPr id="11" name="Picture 10" descr="f-2d62af7528050520.png"/>
           <p:cNvPicPr>
             <a:picLocks noChangeAspect="1"/>
           </p:cNvPicPr>
@@ -48723,8 +48571,8 @@
         </p:blipFill>
         <p:spPr>
           <a:xfrm>
-            <a:off x="1177732" y="2103120"/>
-            <a:ext cx="9714615" cy="3703320"/>
+            <a:off x="2529632" y="2852928"/>
+            <a:ext cx="7010814" cy="868680"/>
           </a:xfrm>
           <a:prstGeom prst="rect">
             <a:avLst/>
@@ -48733,13 +48581,198 @@
       </p:pic>
       <p:sp>
         <p:nvSpPr>
-          <p:cNvPr id="10" name="TextBox 9"/>
-          <p:cNvSpPr txBox="1"/>
-          <p:nvPr/>
-        </p:nvSpPr>
-        <p:spPr>
-          <a:xfrm>
-            <a:off x="548640" y="6309360"/>
+          <p:cNvPr id="12" name="TextBox 11"/>
+          <p:cNvSpPr txBox="1"/>
+          <p:nvPr/>
+        </p:nvSpPr>
+        <p:spPr>
+          <a:xfrm>
+            <a:off x="914400" y="3840480"/>
+            <a:ext cx="10241280" cy="256032"/>
+          </a:xfrm>
+          <a:prstGeom prst="rect">
+            <a:avLst/>
+          </a:prstGeom>
+          <a:noFill/>
+        </p:spPr>
+        <p:txBody>
+          <a:bodyPr wrap="square" anchor="t">
+            <a:spAutoFit/>
+          </a:bodyPr>
+          <a:lstStyle/>
+          <a:p>
+            <a:pPr algn="ctr"/>
+            <a:r>
+              <a:rPr sz="1200" b="0">
+                <a:solidFill>
+                  <a:srgbClr val="5A5470"/>
+                </a:solidFill>
+                <a:latin typeface="DIN Next LT W23"/>
+                <a:ea typeface="DIN Next LT W23"/>
+                <a:cs typeface="DIN Next LT W23"/>
+              </a:rPr>
+              <a:t>Same weights at every timestep  ·  hₜ is a running memory of the past</a:t>
+            </a:r>
+          </a:p>
+        </p:txBody>
+      </p:sp>
+      <p:sp>
+        <p:nvSpPr>
+          <p:cNvPr id="13" name="TextBox 12"/>
+          <p:cNvSpPr txBox="1"/>
+          <p:nvPr/>
+        </p:nvSpPr>
+        <p:spPr>
+          <a:xfrm>
+            <a:off x="548640" y="4270248"/>
+            <a:ext cx="320040" cy="384048"/>
+          </a:xfrm>
+          <a:prstGeom prst="rect">
+            <a:avLst/>
+          </a:prstGeom>
+          <a:noFill/>
+        </p:spPr>
+        <p:txBody>
+          <a:bodyPr wrap="square" anchor="t">
+            <a:spAutoFit/>
+          </a:bodyPr>
+          <a:lstStyle/>
+          <a:p>
+            <a:pPr algn="l"/>
+            <a:r>
+              <a:rPr sz="1300" b="0">
+                <a:solidFill>
+                  <a:srgbClr val="9E59CD"/>
+                </a:solidFill>
+                <a:latin typeface="DIN Next LT W23"/>
+                <a:ea typeface="DIN Next LT W23"/>
+                <a:cs typeface="DIN Next LT W23"/>
+              </a:rPr>
+              <a:t>–</a:t>
+            </a:r>
+          </a:p>
+        </p:txBody>
+      </p:sp>
+      <p:sp>
+        <p:nvSpPr>
+          <p:cNvPr id="14" name="TextBox 13"/>
+          <p:cNvSpPr txBox="1"/>
+          <p:nvPr/>
+        </p:nvSpPr>
+        <p:spPr>
+          <a:xfrm>
+            <a:off x="914400" y="4270248"/>
+            <a:ext cx="9875519" cy="384048"/>
+          </a:xfrm>
+          <a:prstGeom prst="rect">
+            <a:avLst/>
+          </a:prstGeom>
+          <a:noFill/>
+        </p:spPr>
+        <p:txBody>
+          <a:bodyPr wrap="square" anchor="t">
+            <a:spAutoFit/>
+          </a:bodyPr>
+          <a:lstStyle/>
+          <a:p>
+            <a:pPr algn="l"/>
+            <a:r>
+              <a:rPr sz="1300" b="0">
+                <a:solidFill>
+                  <a:srgbClr val="121018"/>
+                </a:solidFill>
+                <a:latin typeface="DIN Next LT W23"/>
+                <a:ea typeface="DIN Next LT W23"/>
+                <a:cs typeface="DIN Next LT W23"/>
+              </a:rPr>
+              <a:t>Parameter sharing across time is efficient — but long sequences multiply Jacobians.</a:t>
+            </a:r>
+          </a:p>
+        </p:txBody>
+      </p:sp>
+      <p:sp>
+        <p:nvSpPr>
+          <p:cNvPr id="15" name="TextBox 14"/>
+          <p:cNvSpPr txBox="1"/>
+          <p:nvPr/>
+        </p:nvSpPr>
+        <p:spPr>
+          <a:xfrm>
+            <a:off x="548640" y="4690872"/>
+            <a:ext cx="320040" cy="384048"/>
+          </a:xfrm>
+          <a:prstGeom prst="rect">
+            <a:avLst/>
+          </a:prstGeom>
+          <a:noFill/>
+        </p:spPr>
+        <p:txBody>
+          <a:bodyPr wrap="square" anchor="t">
+            <a:spAutoFit/>
+          </a:bodyPr>
+          <a:lstStyle/>
+          <a:p>
+            <a:pPr algn="l"/>
+            <a:r>
+              <a:rPr sz="1300" b="0">
+                <a:solidFill>
+                  <a:srgbClr val="9E59CD"/>
+                </a:solidFill>
+                <a:latin typeface="DIN Next LT W23"/>
+                <a:ea typeface="DIN Next LT W23"/>
+                <a:cs typeface="DIN Next LT W23"/>
+              </a:rPr>
+              <a:t>–</a:t>
+            </a:r>
+          </a:p>
+        </p:txBody>
+      </p:sp>
+      <p:sp>
+        <p:nvSpPr>
+          <p:cNvPr id="16" name="TextBox 15"/>
+          <p:cNvSpPr txBox="1"/>
+          <p:nvPr/>
+        </p:nvSpPr>
+        <p:spPr>
+          <a:xfrm>
+            <a:off x="914400" y="4690872"/>
+            <a:ext cx="9875519" cy="384048"/>
+          </a:xfrm>
+          <a:prstGeom prst="rect">
+            <a:avLst/>
+          </a:prstGeom>
+          <a:noFill/>
+        </p:spPr>
+        <p:txBody>
+          <a:bodyPr wrap="square" anchor="t">
+            <a:spAutoFit/>
+          </a:bodyPr>
+          <a:lstStyle/>
+          <a:p>
+            <a:pPr algn="l"/>
+            <a:r>
+              <a:rPr sz="1300" b="0">
+                <a:solidFill>
+                  <a:srgbClr val="121018"/>
+                </a:solidFill>
+                <a:latin typeface="DIN Next LT W23"/>
+                <a:ea typeface="DIN Next LT W23"/>
+                <a:cs typeface="DIN Next LT W23"/>
+              </a:rPr>
+              <a:t>Vanilla RNNs struggle with long-range dependencies (vanishing / exploding gradients).</a:t>
+            </a:r>
+          </a:p>
+        </p:txBody>
+      </p:sp>
+      <p:sp>
+        <p:nvSpPr>
+          <p:cNvPr id="17" name="TextBox 16"/>
+          <p:cNvSpPr txBox="1"/>
+          <p:nvPr/>
+        </p:nvSpPr>
+        <p:spPr>
+          <a:xfrm>
+            <a:off x="548640" y="5989320"/>
             <a:ext cx="10972800" cy="228600"/>
           </a:xfrm>
           <a:prstGeom prst="rect">
@@ -48755,7 +48788,7 @@
           <a:p>
             <a:pPr algn="l"/>
             <a:r>
-              <a:rPr sz="1100" b="0">
+              <a:rPr sz="1200" b="0">
                 <a:solidFill>
                   <a:srgbClr val="5A5470"/>
                 </a:solidFill>
@@ -48763,14 +48796,14 @@
                 <a:ea typeface="DIN Next LT W23"/>
                 <a:cs typeface="DIN Next LT W23"/>
               </a:rPr>
-              <a:t>Cannot fully parallelize timesteps — each hₜ waits on hₜ₋₁.</a:t>
-            </a:r>
-          </a:p>
-        </p:txBody>
-      </p:sp>
-      <p:sp>
-        <p:nvSpPr>
-          <p:cNvPr id="11" name="Rectangle 10"/>
+              <a:t>Backprop through 50 steps ≈ multiplying a matrix 50 times.</a:t>
+            </a:r>
+          </a:p>
+        </p:txBody>
+      </p:sp>
+      <p:sp>
+        <p:nvSpPr>
+          <p:cNvPr id="18" name="Rectangle 17"/>
           <p:cNvSpPr/>
           <p:nvPr/>
         </p:nvSpPr>
@@ -48814,7 +48847,7 @@
       </p:sp>
       <p:sp>
         <p:nvSpPr>
-          <p:cNvPr id="12" name="TextBox 11"/>
+          <p:cNvPr id="19" name="TextBox 18"/>
           <p:cNvSpPr txBox="1"/>
           <p:nvPr/>
         </p:nvSpPr>
@@ -48851,7 +48884,7 @@
       </p:sp>
       <p:sp>
         <p:nvSpPr>
-          <p:cNvPr id="13" name="TextBox 12"/>
+          <p:cNvPr id="20" name="TextBox 19"/>
           <p:cNvSpPr txBox="1"/>
           <p:nvPr/>
         </p:nvSpPr>
@@ -48881,7 +48914,7 @@
                 <a:ea typeface="DIN Next LT W23"/>
                 <a:cs typeface="DIN Next LT W23"/>
               </a:rPr>
-              <a:t>74  /  78</a:t>
+              <a:t>74  /  79</a:t>
             </a:r>
           </a:p>
         </p:txBody>
@@ -49093,7 +49126,7 @@
                 <a:ea typeface="DIN Next LT W23"/>
                 <a:cs typeface="DIN Next LT W23"/>
               </a:rPr>
-              <a:t>LSTM: Gates for Long-Term Memory</a:t>
+              <a:t>RNN Unfolded Through Time</a:t>
             </a:r>
           </a:p>
         </p:txBody>
@@ -49130,57 +49163,20 @@
                 <a:ea typeface="DIN Next LT W23"/>
                 <a:cs typeface="DIN Next LT W23"/>
               </a:rPr>
-              <a:t>Forget, Input, Output — Cell State Flows Linearly</a:t>
-            </a:r>
-          </a:p>
-        </p:txBody>
-      </p:sp>
-      <p:sp>
-        <p:nvSpPr>
-          <p:cNvPr id="8" name="TextBox 7"/>
-          <p:cNvSpPr txBox="1"/>
-          <p:nvPr/>
-        </p:nvSpPr>
-        <p:spPr>
-          <a:xfrm>
-            <a:off x="548640" y="1920240"/>
-            <a:ext cx="10972800" cy="320040"/>
-          </a:xfrm>
-          <a:prstGeom prst="rect">
-            <a:avLst/>
-          </a:prstGeom>
-          <a:noFill/>
-        </p:spPr>
-        <p:txBody>
-          <a:bodyPr wrap="square" anchor="t">
-            <a:spAutoFit/>
-          </a:bodyPr>
-          <a:lstStyle/>
-          <a:p>
-            <a:pPr algn="l"/>
-            <a:r>
-              <a:rPr sz="1300" b="0">
-                <a:solidFill>
-                  <a:srgbClr val="5A5470"/>
-                </a:solidFill>
-                <a:latin typeface="DIN Next LT W23"/>
-                <a:ea typeface="DIN Next LT W23"/>
-                <a:cs typeface="DIN Next LT W23"/>
-              </a:rPr>
-              <a:t>LSTM adds a cell state cₜ with an additive path, so signal can travel many steps without vanishing.</a:t>
-            </a:r>
-          </a:p>
-        </p:txBody>
-      </p:sp>
-      <p:sp>
-        <p:nvSpPr>
-          <p:cNvPr id="9" name="Rounded Rectangle 8"/>
+              <a:t>Rolled Cell = Shared Weights Across Steps</a:t>
+            </a:r>
+          </a:p>
+        </p:txBody>
+      </p:sp>
+      <p:sp>
+        <p:nvSpPr>
+          <p:cNvPr id="8" name="Rounded Rectangle 7"/>
           <p:cNvSpPr/>
           <p:nvPr/>
         </p:nvSpPr>
         <p:spPr>
           <a:xfrm>
-            <a:off x="548640" y="2240280"/>
+            <a:off x="548640" y="1965960"/>
             <a:ext cx="10972800" cy="3977639"/>
           </a:xfrm>
           <a:prstGeom prst="roundRect">
@@ -49220,7 +49216,7 @@
       </p:sp>
       <p:pic>
         <p:nvPicPr>
-          <p:cNvPr id="10" name="Picture 9" descr="lstm-gates.png"/>
+          <p:cNvPr id="9" name="Picture 8" descr="rnn-unfold.png"/>
           <p:cNvPicPr>
             <a:picLocks noChangeAspect="1"/>
           </p:cNvPicPr>
@@ -49234,8 +49230,8 @@
         </p:blipFill>
         <p:spPr>
           <a:xfrm>
-            <a:off x="1056046" y="2377440"/>
-            <a:ext cx="9957987" cy="3703320"/>
+            <a:off x="1177732" y="2103120"/>
+            <a:ext cx="9714615" cy="3703320"/>
           </a:xfrm>
           <a:prstGeom prst="rect">
             <a:avLst/>
@@ -49244,7 +49240,7 @@
       </p:pic>
       <p:sp>
         <p:nvSpPr>
-          <p:cNvPr id="11" name="TextBox 10"/>
+          <p:cNvPr id="10" name="TextBox 9"/>
           <p:cNvSpPr txBox="1"/>
           <p:nvPr/>
         </p:nvSpPr>
@@ -49274,14 +49270,14 @@
                 <a:ea typeface="DIN Next LT W23"/>
                 <a:cs typeface="DIN Next LT W23"/>
               </a:rPr>
-              <a:t>GRU is a simpler cousin (two gates). Transformers later replace recurrence with attention.</a:t>
-            </a:r>
-          </a:p>
-        </p:txBody>
-      </p:sp>
-      <p:sp>
-        <p:nvSpPr>
-          <p:cNvPr id="12" name="Rectangle 11"/>
+              <a:t>Cannot fully parallelize timesteps — each hₜ waits on hₜ₋₁.</a:t>
+            </a:r>
+          </a:p>
+        </p:txBody>
+      </p:sp>
+      <p:sp>
+        <p:nvSpPr>
+          <p:cNvPr id="11" name="Rectangle 10"/>
           <p:cNvSpPr/>
           <p:nvPr/>
         </p:nvSpPr>
@@ -49325,7 +49321,7 @@
       </p:sp>
       <p:sp>
         <p:nvSpPr>
-          <p:cNvPr id="13" name="TextBox 12"/>
+          <p:cNvPr id="12" name="TextBox 11"/>
           <p:cNvSpPr txBox="1"/>
           <p:nvPr/>
         </p:nvSpPr>
@@ -49362,7 +49358,7 @@
       </p:sp>
       <p:sp>
         <p:nvSpPr>
-          <p:cNvPr id="14" name="TextBox 13"/>
+          <p:cNvPr id="13" name="TextBox 12"/>
           <p:cNvSpPr txBox="1"/>
           <p:nvPr/>
         </p:nvSpPr>
@@ -49392,7 +49388,7 @@
                 <a:ea typeface="DIN Next LT W23"/>
                 <a:cs typeface="DIN Next LT W23"/>
               </a:rPr>
-              <a:t>75  /  78</a:t>
+              <a:t>75  /  79</a:t>
             </a:r>
           </a:p>
         </p:txBody>
@@ -49406,6 +49402,517 @@
 </file>
 
 <file path=ppt/slides/slide76.xml><?xml version="1.0" encoding="utf-8"?>
+<p:sld xmlns:a="http://schemas.openxmlformats.org/drawingml/2006/main" xmlns:p="http://schemas.openxmlformats.org/presentationml/2006/main" xmlns:r="http://schemas.openxmlformats.org/officeDocument/2006/relationships">
+  <p:cSld>
+    <p:bg>
+      <p:bgPr>
+        <a:solidFill>
+          <a:srgbClr val="FAF8FF"/>
+        </a:solidFill>
+        <a:effectLst/>
+      </p:bgPr>
+    </p:bg>
+    <p:spTree>
+      <p:nvGrpSpPr>
+        <p:cNvPr id="1" name=""/>
+        <p:cNvGrpSpPr/>
+        <p:nvPr/>
+      </p:nvGrpSpPr>
+      <p:grpSpPr/>
+      <p:sp>
+        <p:nvSpPr>
+          <p:cNvPr id="2" name="Rectangle 1"/>
+          <p:cNvSpPr/>
+          <p:nvPr/>
+        </p:nvSpPr>
+        <p:spPr>
+          <a:xfrm>
+            <a:off x="12136831" y="0"/>
+            <a:ext cx="54864" cy="6858000"/>
+          </a:xfrm>
+          <a:prstGeom prst="rect">
+            <a:avLst/>
+          </a:prstGeom>
+          <a:solidFill>
+            <a:srgbClr val="5234B7"/>
+          </a:solidFill>
+          <a:ln>
+            <a:noFill/>
+          </a:ln>
+          <a:effectLst/>
+        </p:spPr>
+        <p:style>
+          <a:lnRef idx="1">
+            <a:schemeClr val="accent1"/>
+          </a:lnRef>
+          <a:fillRef idx="3">
+            <a:schemeClr val="accent1"/>
+          </a:fillRef>
+          <a:effectRef idx="2">
+            <a:schemeClr val="accent1"/>
+          </a:effectRef>
+          <a:fontRef idx="minor">
+            <a:schemeClr val="lt1"/>
+          </a:fontRef>
+        </p:style>
+        <p:txBody>
+          <a:bodyPr rtlCol="0" anchor="ctr"/>
+          <a:lstStyle/>
+          <a:p>
+            <a:pPr algn="ctr"/>
+          </a:p>
+        </p:txBody>
+      </p:sp>
+      <p:pic>
+        <p:nvPicPr>
+          <p:cNvPr id="3" name="Picture 2" descr="etra-wordmark.png"/>
+          <p:cNvPicPr>
+            <a:picLocks noChangeAspect="1"/>
+          </p:cNvPicPr>
+          <p:nvPr/>
+        </p:nvPicPr>
+        <p:blipFill>
+          <a:blip r:embed="rId2"/>
+          <a:stretch>
+            <a:fillRect/>
+          </a:stretch>
+        </p:blipFill>
+        <p:spPr>
+          <a:xfrm>
+            <a:off x="10561320" y="411480"/>
+            <a:ext cx="1206201" cy="320040"/>
+          </a:xfrm>
+          <a:prstGeom prst="rect">
+            <a:avLst/>
+          </a:prstGeom>
+        </p:spPr>
+      </p:pic>
+      <p:sp>
+        <p:nvSpPr>
+          <p:cNvPr id="4" name="TextBox 3"/>
+          <p:cNvSpPr txBox="1"/>
+          <p:nvPr/>
+        </p:nvSpPr>
+        <p:spPr>
+          <a:xfrm>
+            <a:off x="548640" y="438912"/>
+            <a:ext cx="7772400" cy="274320"/>
+          </a:xfrm>
+          <a:prstGeom prst="rect">
+            <a:avLst/>
+          </a:prstGeom>
+          <a:noFill/>
+        </p:spPr>
+        <p:txBody>
+          <a:bodyPr wrap="square" anchor="t">
+            <a:spAutoFit/>
+          </a:bodyPr>
+          <a:lstStyle/>
+          <a:p>
+            <a:pPr algn="l"/>
+            <a:r>
+              <a:rPr sz="1200" b="0">
+                <a:solidFill>
+                  <a:srgbClr val="5A5470"/>
+                </a:solidFill>
+                <a:latin typeface="DIN Next LT W23"/>
+                <a:ea typeface="DIN Next LT W23"/>
+                <a:cs typeface="DIN Next LT W23"/>
+              </a:rPr>
+              <a:t>S07  ·  Deep Learning</a:t>
+            </a:r>
+          </a:p>
+        </p:txBody>
+      </p:sp>
+      <p:sp>
+        <p:nvSpPr>
+          <p:cNvPr id="5" name="Rectangle 4"/>
+          <p:cNvSpPr/>
+          <p:nvPr/>
+        </p:nvSpPr>
+        <p:spPr>
+          <a:xfrm>
+            <a:off x="548640" y="822960"/>
+            <a:ext cx="11064240" cy="10972"/>
+          </a:xfrm>
+          <a:prstGeom prst="rect">
+            <a:avLst/>
+          </a:prstGeom>
+          <a:solidFill>
+            <a:srgbClr val="E4DCF4"/>
+          </a:solidFill>
+          <a:ln>
+            <a:noFill/>
+          </a:ln>
+          <a:effectLst/>
+        </p:spPr>
+        <p:style>
+          <a:lnRef idx="1">
+            <a:schemeClr val="accent1"/>
+          </a:lnRef>
+          <a:fillRef idx="3">
+            <a:schemeClr val="accent1"/>
+          </a:fillRef>
+          <a:effectRef idx="2">
+            <a:schemeClr val="accent1"/>
+          </a:effectRef>
+          <a:fontRef idx="minor">
+            <a:schemeClr val="lt1"/>
+          </a:fontRef>
+        </p:style>
+        <p:txBody>
+          <a:bodyPr rtlCol="0" anchor="ctr"/>
+          <a:lstStyle/>
+          <a:p>
+            <a:pPr algn="ctr"/>
+          </a:p>
+        </p:txBody>
+      </p:sp>
+      <p:sp>
+        <p:nvSpPr>
+          <p:cNvPr id="6" name="TextBox 5"/>
+          <p:cNvSpPr txBox="1"/>
+          <p:nvPr/>
+        </p:nvSpPr>
+        <p:spPr>
+          <a:xfrm>
+            <a:off x="548640" y="1051560"/>
+            <a:ext cx="10241280" cy="594360"/>
+          </a:xfrm>
+          <a:prstGeom prst="rect">
+            <a:avLst/>
+          </a:prstGeom>
+          <a:noFill/>
+        </p:spPr>
+        <p:txBody>
+          <a:bodyPr wrap="square" anchor="t">
+            <a:spAutoFit/>
+          </a:bodyPr>
+          <a:lstStyle/>
+          <a:p>
+            <a:pPr algn="l"/>
+            <a:r>
+              <a:rPr sz="3200" b="1">
+                <a:solidFill>
+                  <a:srgbClr val="5234B7"/>
+                </a:solidFill>
+                <a:latin typeface="DIN Next LT W23"/>
+                <a:ea typeface="DIN Next LT W23"/>
+                <a:cs typeface="DIN Next LT W23"/>
+              </a:rPr>
+              <a:t>LSTM: Gates for Long-Term Memory</a:t>
+            </a:r>
+          </a:p>
+        </p:txBody>
+      </p:sp>
+      <p:sp>
+        <p:nvSpPr>
+          <p:cNvPr id="7" name="TextBox 6"/>
+          <p:cNvSpPr txBox="1"/>
+          <p:nvPr/>
+        </p:nvSpPr>
+        <p:spPr>
+          <a:xfrm>
+            <a:off x="548640" y="1600200"/>
+            <a:ext cx="10241280" cy="365760"/>
+          </a:xfrm>
+          <a:prstGeom prst="rect">
+            <a:avLst/>
+          </a:prstGeom>
+          <a:noFill/>
+        </p:spPr>
+        <p:txBody>
+          <a:bodyPr wrap="square" anchor="t">
+            <a:spAutoFit/>
+          </a:bodyPr>
+          <a:lstStyle/>
+          <a:p>
+            <a:pPr algn="l"/>
+            <a:r>
+              <a:rPr sz="1500" b="0">
+                <a:solidFill>
+                  <a:srgbClr val="5A5470"/>
+                </a:solidFill>
+                <a:latin typeface="DIN Next LT W23"/>
+                <a:ea typeface="DIN Next LT W23"/>
+                <a:cs typeface="DIN Next LT W23"/>
+              </a:rPr>
+              <a:t>Forget, Input, Output — Cell State Flows Linearly</a:t>
+            </a:r>
+          </a:p>
+        </p:txBody>
+      </p:sp>
+      <p:sp>
+        <p:nvSpPr>
+          <p:cNvPr id="8" name="TextBox 7"/>
+          <p:cNvSpPr txBox="1"/>
+          <p:nvPr/>
+        </p:nvSpPr>
+        <p:spPr>
+          <a:xfrm>
+            <a:off x="548640" y="1920240"/>
+            <a:ext cx="10972800" cy="320040"/>
+          </a:xfrm>
+          <a:prstGeom prst="rect">
+            <a:avLst/>
+          </a:prstGeom>
+          <a:noFill/>
+        </p:spPr>
+        <p:txBody>
+          <a:bodyPr wrap="square" anchor="t">
+            <a:spAutoFit/>
+          </a:bodyPr>
+          <a:lstStyle/>
+          <a:p>
+            <a:pPr algn="l"/>
+            <a:r>
+              <a:rPr sz="1300" b="0">
+                <a:solidFill>
+                  <a:srgbClr val="5A5470"/>
+                </a:solidFill>
+                <a:latin typeface="DIN Next LT W23"/>
+                <a:ea typeface="DIN Next LT W23"/>
+                <a:cs typeface="DIN Next LT W23"/>
+              </a:rPr>
+              <a:t>LSTM adds a cell state cₜ with an additive path, so signal can travel many steps without vanishing.</a:t>
+            </a:r>
+          </a:p>
+        </p:txBody>
+      </p:sp>
+      <p:sp>
+        <p:nvSpPr>
+          <p:cNvPr id="9" name="Rounded Rectangle 8"/>
+          <p:cNvSpPr/>
+          <p:nvPr/>
+        </p:nvSpPr>
+        <p:spPr>
+          <a:xfrm>
+            <a:off x="548640" y="2240280"/>
+            <a:ext cx="10972800" cy="3977639"/>
+          </a:xfrm>
+          <a:prstGeom prst="roundRect">
+            <a:avLst>
+              <a:gd name="adj" fmla="val 10000"/>
+            </a:avLst>
+          </a:prstGeom>
+          <a:solidFill>
+            <a:srgbClr val="EEE8FA"/>
+          </a:solidFill>
+          <a:ln>
+            <a:noFill/>
+          </a:ln>
+          <a:effectLst/>
+        </p:spPr>
+        <p:style>
+          <a:lnRef idx="1">
+            <a:schemeClr val="accent1"/>
+          </a:lnRef>
+          <a:fillRef idx="3">
+            <a:schemeClr val="accent1"/>
+          </a:fillRef>
+          <a:effectRef idx="2">
+            <a:schemeClr val="accent1"/>
+          </a:effectRef>
+          <a:fontRef idx="minor">
+            <a:schemeClr val="lt1"/>
+          </a:fontRef>
+        </p:style>
+        <p:txBody>
+          <a:bodyPr rtlCol="0" anchor="ctr"/>
+          <a:lstStyle/>
+          <a:p>
+            <a:pPr algn="ctr"/>
+          </a:p>
+        </p:txBody>
+      </p:sp>
+      <p:pic>
+        <p:nvPicPr>
+          <p:cNvPr id="10" name="Picture 9" descr="lstm-gates.png"/>
+          <p:cNvPicPr>
+            <a:picLocks noChangeAspect="1"/>
+          </p:cNvPicPr>
+          <p:nvPr/>
+        </p:nvPicPr>
+        <p:blipFill>
+          <a:blip r:embed="rId3"/>
+          <a:stretch>
+            <a:fillRect/>
+          </a:stretch>
+        </p:blipFill>
+        <p:spPr>
+          <a:xfrm>
+            <a:off x="1056046" y="2377440"/>
+            <a:ext cx="9957987" cy="3703320"/>
+          </a:xfrm>
+          <a:prstGeom prst="rect">
+            <a:avLst/>
+          </a:prstGeom>
+        </p:spPr>
+      </p:pic>
+      <p:sp>
+        <p:nvSpPr>
+          <p:cNvPr id="11" name="TextBox 10"/>
+          <p:cNvSpPr txBox="1"/>
+          <p:nvPr/>
+        </p:nvSpPr>
+        <p:spPr>
+          <a:xfrm>
+            <a:off x="548640" y="6309360"/>
+            <a:ext cx="10972800" cy="228600"/>
+          </a:xfrm>
+          <a:prstGeom prst="rect">
+            <a:avLst/>
+          </a:prstGeom>
+          <a:noFill/>
+        </p:spPr>
+        <p:txBody>
+          <a:bodyPr wrap="square" anchor="t">
+            <a:spAutoFit/>
+          </a:bodyPr>
+          <a:lstStyle/>
+          <a:p>
+            <a:pPr algn="l"/>
+            <a:r>
+              <a:rPr sz="1100" b="0">
+                <a:solidFill>
+                  <a:srgbClr val="5A5470"/>
+                </a:solidFill>
+                <a:latin typeface="DIN Next LT W23"/>
+                <a:ea typeface="DIN Next LT W23"/>
+                <a:cs typeface="DIN Next LT W23"/>
+              </a:rPr>
+              <a:t>GRU is a simpler cousin (two gates). Transformers later replace recurrence with attention.</a:t>
+            </a:r>
+          </a:p>
+        </p:txBody>
+      </p:sp>
+      <p:sp>
+        <p:nvSpPr>
+          <p:cNvPr id="12" name="Rectangle 11"/>
+          <p:cNvSpPr/>
+          <p:nvPr/>
+        </p:nvSpPr>
+        <p:spPr>
+          <a:xfrm>
+            <a:off x="548640" y="6446520"/>
+            <a:ext cx="11064240" cy="10972"/>
+          </a:xfrm>
+          <a:prstGeom prst="rect">
+            <a:avLst/>
+          </a:prstGeom>
+          <a:solidFill>
+            <a:srgbClr val="5234B7"/>
+          </a:solidFill>
+          <a:ln>
+            <a:noFill/>
+          </a:ln>
+          <a:effectLst/>
+        </p:spPr>
+        <p:style>
+          <a:lnRef idx="1">
+            <a:schemeClr val="accent1"/>
+          </a:lnRef>
+          <a:fillRef idx="3">
+            <a:schemeClr val="accent1"/>
+          </a:fillRef>
+          <a:effectRef idx="2">
+            <a:schemeClr val="accent1"/>
+          </a:effectRef>
+          <a:fontRef idx="minor">
+            <a:schemeClr val="lt1"/>
+          </a:fontRef>
+        </p:style>
+        <p:txBody>
+          <a:bodyPr rtlCol="0" anchor="ctr"/>
+          <a:lstStyle/>
+          <a:p>
+            <a:pPr algn="ctr"/>
+          </a:p>
+        </p:txBody>
+      </p:sp>
+      <p:sp>
+        <p:nvSpPr>
+          <p:cNvPr id="13" name="TextBox 12"/>
+          <p:cNvSpPr txBox="1"/>
+          <p:nvPr/>
+        </p:nvSpPr>
+        <p:spPr>
+          <a:xfrm>
+            <a:off x="548640" y="6510528"/>
+            <a:ext cx="2743200" cy="256032"/>
+          </a:xfrm>
+          <a:prstGeom prst="rect">
+            <a:avLst/>
+          </a:prstGeom>
+          <a:noFill/>
+        </p:spPr>
+        <p:txBody>
+          <a:bodyPr wrap="square" anchor="t">
+            <a:spAutoFit/>
+          </a:bodyPr>
+          <a:lstStyle/>
+          <a:p>
+            <a:pPr algn="l"/>
+            <a:r>
+              <a:rPr sz="1100" b="1">
+                <a:solidFill>
+                  <a:srgbClr val="5234B7"/>
+                </a:solidFill>
+                <a:latin typeface="DIN Next LT W23"/>
+                <a:ea typeface="DIN Next LT W23"/>
+                <a:cs typeface="DIN Next LT W23"/>
+              </a:rPr>
+              <a:t>ETRA</a:t>
+            </a:r>
+          </a:p>
+        </p:txBody>
+      </p:sp>
+      <p:sp>
+        <p:nvSpPr>
+          <p:cNvPr id="14" name="TextBox 13"/>
+          <p:cNvSpPr txBox="1"/>
+          <p:nvPr/>
+        </p:nvSpPr>
+        <p:spPr>
+          <a:xfrm>
+            <a:off x="9601200" y="6510528"/>
+            <a:ext cx="2011680" cy="256032"/>
+          </a:xfrm>
+          <a:prstGeom prst="rect">
+            <a:avLst/>
+          </a:prstGeom>
+          <a:noFill/>
+        </p:spPr>
+        <p:txBody>
+          <a:bodyPr wrap="square" anchor="t">
+            <a:spAutoFit/>
+          </a:bodyPr>
+          <a:lstStyle/>
+          <a:p>
+            <a:pPr algn="r"/>
+            <a:r>
+              <a:rPr sz="1100" b="0">
+                <a:solidFill>
+                  <a:srgbClr val="5A5470"/>
+                </a:solidFill>
+                <a:latin typeface="DIN Next LT W23"/>
+                <a:ea typeface="DIN Next LT W23"/>
+                <a:cs typeface="DIN Next LT W23"/>
+              </a:rPr>
+              <a:t>76  /  79</a:t>
+            </a:r>
+          </a:p>
+        </p:txBody>
+      </p:sp>
+    </p:spTree>
+  </p:cSld>
+  <p:clrMapOvr>
+    <a:masterClrMapping/>
+  </p:clrMapOvr>
+</p:sld>
+</file>
+
+<file path=ppt/slides/slide77.xml><?xml version="1.0" encoding="utf-8"?>
 <p:sld xmlns:a="http://schemas.openxmlformats.org/drawingml/2006/main" xmlns:p="http://schemas.openxmlformats.org/presentationml/2006/main" xmlns:r="http://schemas.openxmlformats.org/officeDocument/2006/relationships">
   <p:cSld>
     <p:bg>
@@ -50060,734 +50567,7 @@
                 <a:ea typeface="DIN Next LT W23"/>
                 <a:cs typeface="DIN Next LT W23"/>
               </a:rPr>
-              <a:t>76  /  78</a:t>
-            </a:r>
-          </a:p>
-        </p:txBody>
-      </p:sp>
-    </p:spTree>
-  </p:cSld>
-  <p:clrMapOvr>
-    <a:masterClrMapping/>
-  </p:clrMapOvr>
-</p:sld>
-</file>
-
-<file path=ppt/slides/slide77.xml><?xml version="1.0" encoding="utf-8"?>
-<p:sld xmlns:a="http://schemas.openxmlformats.org/drawingml/2006/main" xmlns:p="http://schemas.openxmlformats.org/presentationml/2006/main" xmlns:r="http://schemas.openxmlformats.org/officeDocument/2006/relationships">
-  <p:cSld>
-    <p:bg>
-      <p:bgPr>
-        <a:solidFill>
-          <a:srgbClr val="FAF8FF"/>
-        </a:solidFill>
-        <a:effectLst/>
-      </p:bgPr>
-    </p:bg>
-    <p:spTree>
-      <p:nvGrpSpPr>
-        <p:cNvPr id="1" name=""/>
-        <p:cNvGrpSpPr/>
-        <p:nvPr/>
-      </p:nvGrpSpPr>
-      <p:grpSpPr/>
-      <p:sp>
-        <p:nvSpPr>
-          <p:cNvPr id="2" name="Rectangle 1"/>
-          <p:cNvSpPr/>
-          <p:nvPr/>
-        </p:nvSpPr>
-        <p:spPr>
-          <a:xfrm>
-            <a:off x="12136831" y="0"/>
-            <a:ext cx="54864" cy="6858000"/>
-          </a:xfrm>
-          <a:prstGeom prst="rect">
-            <a:avLst/>
-          </a:prstGeom>
-          <a:solidFill>
-            <a:srgbClr val="5234B7"/>
-          </a:solidFill>
-          <a:ln>
-            <a:noFill/>
-          </a:ln>
-          <a:effectLst/>
-        </p:spPr>
-        <p:style>
-          <a:lnRef idx="1">
-            <a:schemeClr val="accent1"/>
-          </a:lnRef>
-          <a:fillRef idx="3">
-            <a:schemeClr val="accent1"/>
-          </a:fillRef>
-          <a:effectRef idx="2">
-            <a:schemeClr val="accent1"/>
-          </a:effectRef>
-          <a:fontRef idx="minor">
-            <a:schemeClr val="lt1"/>
-          </a:fontRef>
-        </p:style>
-        <p:txBody>
-          <a:bodyPr rtlCol="0" anchor="ctr"/>
-          <a:lstStyle/>
-          <a:p>
-            <a:pPr algn="ctr"/>
-          </a:p>
-        </p:txBody>
-      </p:sp>
-      <p:pic>
-        <p:nvPicPr>
-          <p:cNvPr id="3" name="Picture 2" descr="etra-wordmark.png"/>
-          <p:cNvPicPr>
-            <a:picLocks noChangeAspect="1"/>
-          </p:cNvPicPr>
-          <p:nvPr/>
-        </p:nvPicPr>
-        <p:blipFill>
-          <a:blip r:embed="rId2"/>
-          <a:stretch>
-            <a:fillRect/>
-          </a:stretch>
-        </p:blipFill>
-        <p:spPr>
-          <a:xfrm>
-            <a:off x="10561320" y="411480"/>
-            <a:ext cx="1206201" cy="320040"/>
-          </a:xfrm>
-          <a:prstGeom prst="rect">
-            <a:avLst/>
-          </a:prstGeom>
-        </p:spPr>
-      </p:pic>
-      <p:sp>
-        <p:nvSpPr>
-          <p:cNvPr id="4" name="TextBox 3"/>
-          <p:cNvSpPr txBox="1"/>
-          <p:nvPr/>
-        </p:nvSpPr>
-        <p:spPr>
-          <a:xfrm>
-            <a:off x="548640" y="438912"/>
-            <a:ext cx="7772400" cy="274320"/>
-          </a:xfrm>
-          <a:prstGeom prst="rect">
-            <a:avLst/>
-          </a:prstGeom>
-          <a:noFill/>
-        </p:spPr>
-        <p:txBody>
-          <a:bodyPr wrap="square" anchor="t">
-            <a:spAutoFit/>
-          </a:bodyPr>
-          <a:lstStyle/>
-          <a:p>
-            <a:pPr algn="l"/>
-            <a:r>
-              <a:rPr sz="1200" b="0">
-                <a:solidFill>
-                  <a:srgbClr val="5A5470"/>
-                </a:solidFill>
-                <a:latin typeface="DIN Next LT W23"/>
-                <a:ea typeface="DIN Next LT W23"/>
-                <a:cs typeface="DIN Next LT W23"/>
-              </a:rPr>
-              <a:t>S07  ·  Takeaways</a:t>
-            </a:r>
-          </a:p>
-        </p:txBody>
-      </p:sp>
-      <p:sp>
-        <p:nvSpPr>
-          <p:cNvPr id="5" name="Rectangle 4"/>
-          <p:cNvSpPr/>
-          <p:nvPr/>
-        </p:nvSpPr>
-        <p:spPr>
-          <a:xfrm>
-            <a:off x="548640" y="822960"/>
-            <a:ext cx="11064240" cy="10972"/>
-          </a:xfrm>
-          <a:prstGeom prst="rect">
-            <a:avLst/>
-          </a:prstGeom>
-          <a:solidFill>
-            <a:srgbClr val="E4DCF4"/>
-          </a:solidFill>
-          <a:ln>
-            <a:noFill/>
-          </a:ln>
-          <a:effectLst/>
-        </p:spPr>
-        <p:style>
-          <a:lnRef idx="1">
-            <a:schemeClr val="accent1"/>
-          </a:lnRef>
-          <a:fillRef idx="3">
-            <a:schemeClr val="accent1"/>
-          </a:fillRef>
-          <a:effectRef idx="2">
-            <a:schemeClr val="accent1"/>
-          </a:effectRef>
-          <a:fontRef idx="minor">
-            <a:schemeClr val="lt1"/>
-          </a:fontRef>
-        </p:style>
-        <p:txBody>
-          <a:bodyPr rtlCol="0" anchor="ctr"/>
-          <a:lstStyle/>
-          <a:p>
-            <a:pPr algn="ctr"/>
-          </a:p>
-        </p:txBody>
-      </p:sp>
-      <p:sp>
-        <p:nvSpPr>
-          <p:cNvPr id="6" name="TextBox 5"/>
-          <p:cNvSpPr txBox="1"/>
-          <p:nvPr/>
-        </p:nvSpPr>
-        <p:spPr>
-          <a:xfrm>
-            <a:off x="548640" y="1051560"/>
-            <a:ext cx="10241280" cy="594360"/>
-          </a:xfrm>
-          <a:prstGeom prst="rect">
-            <a:avLst/>
-          </a:prstGeom>
-          <a:noFill/>
-        </p:spPr>
-        <p:txBody>
-          <a:bodyPr wrap="square" anchor="t">
-            <a:spAutoFit/>
-          </a:bodyPr>
-          <a:lstStyle/>
-          <a:p>
-            <a:pPr algn="l"/>
-            <a:r>
-              <a:rPr sz="3200" b="1">
-                <a:solidFill>
-                  <a:srgbClr val="5234B7"/>
-                </a:solidFill>
-                <a:latin typeface="DIN Next LT W23"/>
-                <a:ea typeface="DIN Next LT W23"/>
-                <a:cs typeface="DIN Next LT W23"/>
-              </a:rPr>
-              <a:t>3 Ideas to Keep</a:t>
-            </a:r>
-          </a:p>
-        </p:txBody>
-      </p:sp>
-      <p:sp>
-        <p:nvSpPr>
-          <p:cNvPr id="7" name="TextBox 6"/>
-          <p:cNvSpPr txBox="1"/>
-          <p:nvPr/>
-        </p:nvSpPr>
-        <p:spPr>
-          <a:xfrm>
-            <a:off x="548640" y="1600200"/>
-            <a:ext cx="10241280" cy="365760"/>
-          </a:xfrm>
-          <a:prstGeom prst="rect">
-            <a:avLst/>
-          </a:prstGeom>
-          <a:noFill/>
-        </p:spPr>
-        <p:txBody>
-          <a:bodyPr wrap="square" anchor="t">
-            <a:spAutoFit/>
-          </a:bodyPr>
-          <a:lstStyle/>
-          <a:p>
-            <a:pPr algn="l"/>
-            <a:r>
-              <a:rPr sz="1500" b="0">
-                <a:solidFill>
-                  <a:srgbClr val="5A5470"/>
-                </a:solidFill>
-                <a:latin typeface="DIN Next LT W23"/>
-                <a:ea typeface="DIN Next LT W23"/>
-                <a:cs typeface="DIN Next LT W23"/>
-              </a:rPr>
-              <a:t>Leave with these</a:t>
-            </a:r>
-          </a:p>
-        </p:txBody>
-      </p:sp>
-      <p:sp>
-        <p:nvSpPr>
-          <p:cNvPr id="8" name="Rounded Rectangle 7"/>
-          <p:cNvSpPr/>
-          <p:nvPr/>
-        </p:nvSpPr>
-        <p:spPr>
-          <a:xfrm>
-            <a:off x="548640" y="2148840"/>
-            <a:ext cx="10972800" cy="987552"/>
-          </a:xfrm>
-          <a:prstGeom prst="roundRect">
-            <a:avLst>
-              <a:gd name="adj" fmla="val 10000"/>
-            </a:avLst>
-          </a:prstGeom>
-          <a:solidFill>
-            <a:srgbClr val="EEE8FA"/>
-          </a:solidFill>
-          <a:ln>
-            <a:noFill/>
-          </a:ln>
-          <a:effectLst/>
-        </p:spPr>
-        <p:style>
-          <a:lnRef idx="1">
-            <a:schemeClr val="accent1"/>
-          </a:lnRef>
-          <a:fillRef idx="3">
-            <a:schemeClr val="accent1"/>
-          </a:fillRef>
-          <a:effectRef idx="2">
-            <a:schemeClr val="accent1"/>
-          </a:effectRef>
-          <a:fontRef idx="minor">
-            <a:schemeClr val="lt1"/>
-          </a:fontRef>
-        </p:style>
-        <p:txBody>
-          <a:bodyPr rtlCol="0" anchor="ctr"/>
-          <a:lstStyle/>
-          <a:p>
-            <a:pPr algn="ctr"/>
-          </a:p>
-        </p:txBody>
-      </p:sp>
-      <p:sp>
-        <p:nvSpPr>
-          <p:cNvPr id="9" name="TextBox 8"/>
-          <p:cNvSpPr txBox="1"/>
-          <p:nvPr/>
-        </p:nvSpPr>
-        <p:spPr>
-          <a:xfrm>
-            <a:off x="822960" y="2404872"/>
-            <a:ext cx="457200" cy="457200"/>
-          </a:xfrm>
-          <a:prstGeom prst="rect">
-            <a:avLst/>
-          </a:prstGeom>
-          <a:noFill/>
-        </p:spPr>
-        <p:txBody>
-          <a:bodyPr wrap="square" anchor="t">
-            <a:spAutoFit/>
-          </a:bodyPr>
-          <a:lstStyle/>
-          <a:p>
-            <a:pPr algn="l"/>
-            <a:r>
-              <a:rPr sz="2200" b="1">
-                <a:solidFill>
-                  <a:srgbClr val="5234B7"/>
-                </a:solidFill>
-                <a:latin typeface="DIN Next LT W23"/>
-                <a:ea typeface="DIN Next LT W23"/>
-                <a:cs typeface="DIN Next LT W23"/>
-              </a:rPr>
-              <a:t>1</a:t>
-            </a:r>
-          </a:p>
-        </p:txBody>
-      </p:sp>
-      <p:sp>
-        <p:nvSpPr>
-          <p:cNvPr id="10" name="TextBox 9"/>
-          <p:cNvSpPr txBox="1"/>
-          <p:nvPr/>
-        </p:nvSpPr>
-        <p:spPr>
-          <a:xfrm>
-            <a:off x="1417320" y="2404872"/>
-            <a:ext cx="9692640" cy="548640"/>
-          </a:xfrm>
-          <a:prstGeom prst="rect">
-            <a:avLst/>
-          </a:prstGeom>
-          <a:noFill/>
-        </p:spPr>
-        <p:txBody>
-          <a:bodyPr wrap="square" anchor="t">
-            <a:spAutoFit/>
-          </a:bodyPr>
-          <a:lstStyle/>
-          <a:p>
-            <a:pPr algn="l"/>
-            <a:r>
-              <a:rPr sz="1600" b="0">
-                <a:solidFill>
-                  <a:srgbClr val="121018"/>
-                </a:solidFill>
-                <a:latin typeface="DIN Next LT W23"/>
-                <a:ea typeface="DIN Next LT W23"/>
-                <a:cs typeface="DIN Next LT W23"/>
-              </a:rPr>
-              <a:t>A neuron is z = wᵀx + b then a = f(z). Depth needs nonlinearity between layers.</a:t>
-            </a:r>
-          </a:p>
-        </p:txBody>
-      </p:sp>
-      <p:sp>
-        <p:nvSpPr>
-          <p:cNvPr id="11" name="Rounded Rectangle 10"/>
-          <p:cNvSpPr/>
-          <p:nvPr/>
-        </p:nvSpPr>
-        <p:spPr>
-          <a:xfrm>
-            <a:off x="548640" y="3291840"/>
-            <a:ext cx="10972800" cy="987552"/>
-          </a:xfrm>
-          <a:prstGeom prst="roundRect">
-            <a:avLst>
-              <a:gd name="adj" fmla="val 10000"/>
-            </a:avLst>
-          </a:prstGeom>
-          <a:solidFill>
-            <a:srgbClr val="EEE8FA"/>
-          </a:solidFill>
-          <a:ln>
-            <a:noFill/>
-          </a:ln>
-          <a:effectLst/>
-        </p:spPr>
-        <p:style>
-          <a:lnRef idx="1">
-            <a:schemeClr val="accent1"/>
-          </a:lnRef>
-          <a:fillRef idx="3">
-            <a:schemeClr val="accent1"/>
-          </a:fillRef>
-          <a:effectRef idx="2">
-            <a:schemeClr val="accent1"/>
-          </a:effectRef>
-          <a:fontRef idx="minor">
-            <a:schemeClr val="lt1"/>
-          </a:fontRef>
-        </p:style>
-        <p:txBody>
-          <a:bodyPr rtlCol="0" anchor="ctr"/>
-          <a:lstStyle/>
-          <a:p>
-            <a:pPr algn="ctr"/>
-          </a:p>
-        </p:txBody>
-      </p:sp>
-      <p:sp>
-        <p:nvSpPr>
-          <p:cNvPr id="12" name="TextBox 11"/>
-          <p:cNvSpPr txBox="1"/>
-          <p:nvPr/>
-        </p:nvSpPr>
-        <p:spPr>
-          <a:xfrm>
-            <a:off x="822960" y="3547872"/>
-            <a:ext cx="457200" cy="457200"/>
-          </a:xfrm>
-          <a:prstGeom prst="rect">
-            <a:avLst/>
-          </a:prstGeom>
-          <a:noFill/>
-        </p:spPr>
-        <p:txBody>
-          <a:bodyPr wrap="square" anchor="t">
-            <a:spAutoFit/>
-          </a:bodyPr>
-          <a:lstStyle/>
-          <a:p>
-            <a:pPr algn="l"/>
-            <a:r>
-              <a:rPr sz="2200" b="1">
-                <a:solidFill>
-                  <a:srgbClr val="5234B7"/>
-                </a:solidFill>
-                <a:latin typeface="DIN Next LT W23"/>
-                <a:ea typeface="DIN Next LT W23"/>
-                <a:cs typeface="DIN Next LT W23"/>
-              </a:rPr>
-              <a:t>2</a:t>
-            </a:r>
-          </a:p>
-        </p:txBody>
-      </p:sp>
-      <p:sp>
-        <p:nvSpPr>
-          <p:cNvPr id="13" name="TextBox 12"/>
-          <p:cNvSpPr txBox="1"/>
-          <p:nvPr/>
-        </p:nvSpPr>
-        <p:spPr>
-          <a:xfrm>
-            <a:off x="1417320" y="3547872"/>
-            <a:ext cx="9692640" cy="548640"/>
-          </a:xfrm>
-          <a:prstGeom prst="rect">
-            <a:avLst/>
-          </a:prstGeom>
-          <a:noFill/>
-        </p:spPr>
-        <p:txBody>
-          <a:bodyPr wrap="square" anchor="t">
-            <a:spAutoFit/>
-          </a:bodyPr>
-          <a:lstStyle/>
-          <a:p>
-            <a:pPr algn="l"/>
-            <a:r>
-              <a:rPr sz="1600" b="0">
-                <a:solidFill>
-                  <a:srgbClr val="121018"/>
-                </a:solidFill>
-                <a:latin typeface="DIN Next LT W23"/>
-                <a:ea typeface="DIN Next LT W23"/>
-                <a:cs typeface="DIN Next LT W23"/>
-              </a:rPr>
-              <a:t>Backprop is the chain rule on a graph. Watch vanishing gradients, LR, and train vs val.</a:t>
-            </a:r>
-          </a:p>
-        </p:txBody>
-      </p:sp>
-      <p:sp>
-        <p:nvSpPr>
-          <p:cNvPr id="14" name="Rounded Rectangle 13"/>
-          <p:cNvSpPr/>
-          <p:nvPr/>
-        </p:nvSpPr>
-        <p:spPr>
-          <a:xfrm>
-            <a:off x="548640" y="4434840"/>
-            <a:ext cx="10972800" cy="987552"/>
-          </a:xfrm>
-          <a:prstGeom prst="roundRect">
-            <a:avLst>
-              <a:gd name="adj" fmla="val 10000"/>
-            </a:avLst>
-          </a:prstGeom>
-          <a:solidFill>
-            <a:srgbClr val="EEE8FA"/>
-          </a:solidFill>
-          <a:ln>
-            <a:noFill/>
-          </a:ln>
-          <a:effectLst/>
-        </p:spPr>
-        <p:style>
-          <a:lnRef idx="1">
-            <a:schemeClr val="accent1"/>
-          </a:lnRef>
-          <a:fillRef idx="3">
-            <a:schemeClr val="accent1"/>
-          </a:fillRef>
-          <a:effectRef idx="2">
-            <a:schemeClr val="accent1"/>
-          </a:effectRef>
-          <a:fontRef idx="minor">
-            <a:schemeClr val="lt1"/>
-          </a:fontRef>
-        </p:style>
-        <p:txBody>
-          <a:bodyPr rtlCol="0" anchor="ctr"/>
-          <a:lstStyle/>
-          <a:p>
-            <a:pPr algn="ctr"/>
-          </a:p>
-        </p:txBody>
-      </p:sp>
-      <p:sp>
-        <p:nvSpPr>
-          <p:cNvPr id="15" name="TextBox 14"/>
-          <p:cNvSpPr txBox="1"/>
-          <p:nvPr/>
-        </p:nvSpPr>
-        <p:spPr>
-          <a:xfrm>
-            <a:off x="822960" y="4690872"/>
-            <a:ext cx="457200" cy="457200"/>
-          </a:xfrm>
-          <a:prstGeom prst="rect">
-            <a:avLst/>
-          </a:prstGeom>
-          <a:noFill/>
-        </p:spPr>
-        <p:txBody>
-          <a:bodyPr wrap="square" anchor="t">
-            <a:spAutoFit/>
-          </a:bodyPr>
-          <a:lstStyle/>
-          <a:p>
-            <a:pPr algn="l"/>
-            <a:r>
-              <a:rPr sz="2200" b="1">
-                <a:solidFill>
-                  <a:srgbClr val="5234B7"/>
-                </a:solidFill>
-                <a:latin typeface="DIN Next LT W23"/>
-                <a:ea typeface="DIN Next LT W23"/>
-                <a:cs typeface="DIN Next LT W23"/>
-              </a:rPr>
-              <a:t>3</a:t>
-            </a:r>
-          </a:p>
-        </p:txBody>
-      </p:sp>
-      <p:sp>
-        <p:nvSpPr>
-          <p:cNvPr id="16" name="TextBox 15"/>
-          <p:cNvSpPr txBox="1"/>
-          <p:nvPr/>
-        </p:nvSpPr>
-        <p:spPr>
-          <a:xfrm>
-            <a:off x="1417320" y="4690872"/>
-            <a:ext cx="9692640" cy="548640"/>
-          </a:xfrm>
-          <a:prstGeom prst="rect">
-            <a:avLst/>
-          </a:prstGeom>
-          <a:noFill/>
-        </p:spPr>
-        <p:txBody>
-          <a:bodyPr wrap="square" anchor="t">
-            <a:spAutoFit/>
-          </a:bodyPr>
-          <a:lstStyle/>
-          <a:p>
-            <a:pPr algn="l"/>
-            <a:r>
-              <a:rPr sz="1600" b="0">
-                <a:solidFill>
-                  <a:srgbClr val="121018"/>
-                </a:solidFill>
-                <a:latin typeface="DIN Next LT W23"/>
-                <a:ea typeface="DIN Next LT W23"/>
-                <a:cs typeface="DIN Next LT W23"/>
-              </a:rPr>
-              <a:t>CNNs share filters across space; RNNs share weights across time; regularize so they generalize.</a:t>
-            </a:r>
-          </a:p>
-        </p:txBody>
-      </p:sp>
-      <p:sp>
-        <p:nvSpPr>
-          <p:cNvPr id="17" name="Rectangle 16"/>
-          <p:cNvSpPr/>
-          <p:nvPr/>
-        </p:nvSpPr>
-        <p:spPr>
-          <a:xfrm>
-            <a:off x="548640" y="6446520"/>
-            <a:ext cx="11064240" cy="10972"/>
-          </a:xfrm>
-          <a:prstGeom prst="rect">
-            <a:avLst/>
-          </a:prstGeom>
-          <a:solidFill>
-            <a:srgbClr val="5234B7"/>
-          </a:solidFill>
-          <a:ln>
-            <a:noFill/>
-          </a:ln>
-          <a:effectLst/>
-        </p:spPr>
-        <p:style>
-          <a:lnRef idx="1">
-            <a:schemeClr val="accent1"/>
-          </a:lnRef>
-          <a:fillRef idx="3">
-            <a:schemeClr val="accent1"/>
-          </a:fillRef>
-          <a:effectRef idx="2">
-            <a:schemeClr val="accent1"/>
-          </a:effectRef>
-          <a:fontRef idx="minor">
-            <a:schemeClr val="lt1"/>
-          </a:fontRef>
-        </p:style>
-        <p:txBody>
-          <a:bodyPr rtlCol="0" anchor="ctr"/>
-          <a:lstStyle/>
-          <a:p>
-            <a:pPr algn="ctr"/>
-          </a:p>
-        </p:txBody>
-      </p:sp>
-      <p:sp>
-        <p:nvSpPr>
-          <p:cNvPr id="18" name="TextBox 17"/>
-          <p:cNvSpPr txBox="1"/>
-          <p:nvPr/>
-        </p:nvSpPr>
-        <p:spPr>
-          <a:xfrm>
-            <a:off x="548640" y="6510528"/>
-            <a:ext cx="2743200" cy="256032"/>
-          </a:xfrm>
-          <a:prstGeom prst="rect">
-            <a:avLst/>
-          </a:prstGeom>
-          <a:noFill/>
-        </p:spPr>
-        <p:txBody>
-          <a:bodyPr wrap="square" anchor="t">
-            <a:spAutoFit/>
-          </a:bodyPr>
-          <a:lstStyle/>
-          <a:p>
-            <a:pPr algn="l"/>
-            <a:r>
-              <a:rPr sz="1100" b="1">
-                <a:solidFill>
-                  <a:srgbClr val="5234B7"/>
-                </a:solidFill>
-                <a:latin typeface="DIN Next LT W23"/>
-                <a:ea typeface="DIN Next LT W23"/>
-                <a:cs typeface="DIN Next LT W23"/>
-              </a:rPr>
-              <a:t>ETRA</a:t>
-            </a:r>
-          </a:p>
-        </p:txBody>
-      </p:sp>
-      <p:sp>
-        <p:nvSpPr>
-          <p:cNvPr id="19" name="TextBox 18"/>
-          <p:cNvSpPr txBox="1"/>
-          <p:nvPr/>
-        </p:nvSpPr>
-        <p:spPr>
-          <a:xfrm>
-            <a:off x="9601200" y="6510528"/>
-            <a:ext cx="2011680" cy="256032"/>
-          </a:xfrm>
-          <a:prstGeom prst="rect">
-            <a:avLst/>
-          </a:prstGeom>
-          <a:noFill/>
-        </p:spPr>
-        <p:txBody>
-          <a:bodyPr wrap="square" anchor="t">
-            <a:spAutoFit/>
-          </a:bodyPr>
-          <a:lstStyle/>
-          <a:p>
-            <a:pPr algn="r"/>
-            <a:r>
-              <a:rPr sz="1100" b="0">
-                <a:solidFill>
-                  <a:srgbClr val="5A5470"/>
-                </a:solidFill>
-                <a:latin typeface="DIN Next LT W23"/>
-                <a:ea typeface="DIN Next LT W23"/>
-                <a:cs typeface="DIN Next LT W23"/>
-              </a:rPr>
-              <a:t>77  /  78</a:t>
+              <a:t>77  /  79</a:t>
             </a:r>
           </a:p>
         </p:txBody>
@@ -50879,7 +50659,7 @@
         <p:spPr>
           <a:xfrm>
             <a:off x="10561320" y="411480"/>
-            <a:ext cx="1378516" cy="365760"/>
+            <a:ext cx="1206201" cy="320040"/>
           </a:xfrm>
           <a:prstGeom prst="rect">
             <a:avLst/>
@@ -50894,23 +50674,104 @@
         </p:nvSpPr>
         <p:spPr>
           <a:xfrm>
-            <a:off x="548640" y="2651760"/>
-            <a:ext cx="10972800" cy="731520"/>
-          </a:xfrm>
-          <a:prstGeom prst="rect">
-            <a:avLst/>
-          </a:prstGeom>
-          <a:noFill/>
-        </p:spPr>
-        <p:txBody>
-          <a:bodyPr wrap="square" anchor="t">
-            <a:spAutoFit/>
-          </a:bodyPr>
+            <a:off x="548640" y="438912"/>
+            <a:ext cx="7772400" cy="274320"/>
+          </a:xfrm>
+          <a:prstGeom prst="rect">
+            <a:avLst/>
+          </a:prstGeom>
+          <a:noFill/>
+        </p:spPr>
+        <p:txBody>
+          <a:bodyPr wrap="square" anchor="t">
+            <a:spAutoFit/>
+          </a:bodyPr>
+          <a:lstStyle/>
+          <a:p>
+            <a:pPr algn="l"/>
+            <a:r>
+              <a:rPr sz="1200" b="0">
+                <a:solidFill>
+                  <a:srgbClr val="5A5470"/>
+                </a:solidFill>
+                <a:latin typeface="DIN Next LT W23"/>
+                <a:ea typeface="DIN Next LT W23"/>
+                <a:cs typeface="DIN Next LT W23"/>
+              </a:rPr>
+              <a:t>S07  ·  Takeaways</a:t>
+            </a:r>
+          </a:p>
+        </p:txBody>
+      </p:sp>
+      <p:sp>
+        <p:nvSpPr>
+          <p:cNvPr id="5" name="Rectangle 4"/>
+          <p:cNvSpPr/>
+          <p:nvPr/>
+        </p:nvSpPr>
+        <p:spPr>
+          <a:xfrm>
+            <a:off x="548640" y="822960"/>
+            <a:ext cx="11064240" cy="10972"/>
+          </a:xfrm>
+          <a:prstGeom prst="rect">
+            <a:avLst/>
+          </a:prstGeom>
+          <a:solidFill>
+            <a:srgbClr val="E4DCF4"/>
+          </a:solidFill>
+          <a:ln>
+            <a:noFill/>
+          </a:ln>
+          <a:effectLst/>
+        </p:spPr>
+        <p:style>
+          <a:lnRef idx="1">
+            <a:schemeClr val="accent1"/>
+          </a:lnRef>
+          <a:fillRef idx="3">
+            <a:schemeClr val="accent1"/>
+          </a:fillRef>
+          <a:effectRef idx="2">
+            <a:schemeClr val="accent1"/>
+          </a:effectRef>
+          <a:fontRef idx="minor">
+            <a:schemeClr val="lt1"/>
+          </a:fontRef>
+        </p:style>
+        <p:txBody>
+          <a:bodyPr rtlCol="0" anchor="ctr"/>
           <a:lstStyle/>
           <a:p>
             <a:pPr algn="ctr"/>
-            <a:r>
-              <a:rPr sz="4000" b="1">
+          </a:p>
+        </p:txBody>
+      </p:sp>
+      <p:sp>
+        <p:nvSpPr>
+          <p:cNvPr id="6" name="TextBox 5"/>
+          <p:cNvSpPr txBox="1"/>
+          <p:nvPr/>
+        </p:nvSpPr>
+        <p:spPr>
+          <a:xfrm>
+            <a:off x="548640" y="1051560"/>
+            <a:ext cx="10241280" cy="594360"/>
+          </a:xfrm>
+          <a:prstGeom prst="rect">
+            <a:avLst/>
+          </a:prstGeom>
+          <a:noFill/>
+        </p:spPr>
+        <p:txBody>
+          <a:bodyPr wrap="square" anchor="t">
+            <a:spAutoFit/>
+          </a:bodyPr>
+          <a:lstStyle/>
+          <a:p>
+            <a:pPr algn="l"/>
+            <a:r>
+              <a:rPr sz="3200" b="1">
                 <a:solidFill>
                   <a:srgbClr val="5234B7"/>
                 </a:solidFill>
@@ -50918,73 +50779,239 @@
                 <a:ea typeface="DIN Next LT W23"/>
                 <a:cs typeface="DIN Next LT W23"/>
               </a:rPr>
-              <a:t>Thank you</a:t>
-            </a:r>
-          </a:p>
-        </p:txBody>
-      </p:sp>
-      <p:sp>
-        <p:nvSpPr>
-          <p:cNvPr id="5" name="TextBox 4"/>
-          <p:cNvSpPr txBox="1"/>
-          <p:nvPr/>
-        </p:nvSpPr>
-        <p:spPr>
-          <a:xfrm>
-            <a:off x="548640" y="3474720"/>
-            <a:ext cx="10972800" cy="365760"/>
-          </a:xfrm>
-          <a:prstGeom prst="rect">
-            <a:avLst/>
-          </a:prstGeom>
-          <a:noFill/>
-        </p:spPr>
-        <p:txBody>
-          <a:bodyPr wrap="square" anchor="t">
-            <a:spAutoFit/>
-          </a:bodyPr>
+              <a:t>3 Ideas to Keep</a:t>
+            </a:r>
+          </a:p>
+        </p:txBody>
+      </p:sp>
+      <p:sp>
+        <p:nvSpPr>
+          <p:cNvPr id="7" name="TextBox 6"/>
+          <p:cNvSpPr txBox="1"/>
+          <p:nvPr/>
+        </p:nvSpPr>
+        <p:spPr>
+          <a:xfrm>
+            <a:off x="548640" y="1600200"/>
+            <a:ext cx="10241280" cy="365760"/>
+          </a:xfrm>
+          <a:prstGeom prst="rect">
+            <a:avLst/>
+          </a:prstGeom>
+          <a:noFill/>
+        </p:spPr>
+        <p:txBody>
+          <a:bodyPr wrap="square" anchor="t">
+            <a:spAutoFit/>
+          </a:bodyPr>
+          <a:lstStyle/>
+          <a:p>
+            <a:pPr algn="l"/>
+            <a:r>
+              <a:rPr sz="1500" b="0">
+                <a:solidFill>
+                  <a:srgbClr val="5A5470"/>
+                </a:solidFill>
+                <a:latin typeface="DIN Next LT W23"/>
+                <a:ea typeface="DIN Next LT W23"/>
+                <a:cs typeface="DIN Next LT W23"/>
+              </a:rPr>
+              <a:t>Leave with these</a:t>
+            </a:r>
+          </a:p>
+        </p:txBody>
+      </p:sp>
+      <p:sp>
+        <p:nvSpPr>
+          <p:cNvPr id="8" name="Rounded Rectangle 7"/>
+          <p:cNvSpPr/>
+          <p:nvPr/>
+        </p:nvSpPr>
+        <p:spPr>
+          <a:xfrm>
+            <a:off x="548640" y="2148840"/>
+            <a:ext cx="10972800" cy="987552"/>
+          </a:xfrm>
+          <a:prstGeom prst="roundRect">
+            <a:avLst>
+              <a:gd name="adj" fmla="val 10000"/>
+            </a:avLst>
+          </a:prstGeom>
+          <a:solidFill>
+            <a:srgbClr val="EEE8FA"/>
+          </a:solidFill>
+          <a:ln>
+            <a:noFill/>
+          </a:ln>
+          <a:effectLst/>
+        </p:spPr>
+        <p:style>
+          <a:lnRef idx="1">
+            <a:schemeClr val="accent1"/>
+          </a:lnRef>
+          <a:fillRef idx="3">
+            <a:schemeClr val="accent1"/>
+          </a:fillRef>
+          <a:effectRef idx="2">
+            <a:schemeClr val="accent1"/>
+          </a:effectRef>
+          <a:fontRef idx="minor">
+            <a:schemeClr val="lt1"/>
+          </a:fontRef>
+        </p:style>
+        <p:txBody>
+          <a:bodyPr rtlCol="0" anchor="ctr"/>
           <a:lstStyle/>
           <a:p>
             <a:pPr algn="ctr"/>
+          </a:p>
+        </p:txBody>
+      </p:sp>
+      <p:sp>
+        <p:nvSpPr>
+          <p:cNvPr id="9" name="TextBox 8"/>
+          <p:cNvSpPr txBox="1"/>
+          <p:nvPr/>
+        </p:nvSpPr>
+        <p:spPr>
+          <a:xfrm>
+            <a:off x="822960" y="2404872"/>
+            <a:ext cx="457200" cy="457200"/>
+          </a:xfrm>
+          <a:prstGeom prst="rect">
+            <a:avLst/>
+          </a:prstGeom>
+          <a:noFill/>
+        </p:spPr>
+        <p:txBody>
+          <a:bodyPr wrap="square" anchor="t">
+            <a:spAutoFit/>
+          </a:bodyPr>
+          <a:lstStyle/>
+          <a:p>
+            <a:pPr algn="l"/>
+            <a:r>
+              <a:rPr sz="2200" b="1">
+                <a:solidFill>
+                  <a:srgbClr val="5234B7"/>
+                </a:solidFill>
+                <a:latin typeface="DIN Next LT W23"/>
+                <a:ea typeface="DIN Next LT W23"/>
+                <a:cs typeface="DIN Next LT W23"/>
+              </a:rPr>
+              <a:t>1</a:t>
+            </a:r>
+          </a:p>
+        </p:txBody>
+      </p:sp>
+      <p:sp>
+        <p:nvSpPr>
+          <p:cNvPr id="10" name="TextBox 9"/>
+          <p:cNvSpPr txBox="1"/>
+          <p:nvPr/>
+        </p:nvSpPr>
+        <p:spPr>
+          <a:xfrm>
+            <a:off x="1417320" y="2404872"/>
+            <a:ext cx="9692640" cy="548640"/>
+          </a:xfrm>
+          <a:prstGeom prst="rect">
+            <a:avLst/>
+          </a:prstGeom>
+          <a:noFill/>
+        </p:spPr>
+        <p:txBody>
+          <a:bodyPr wrap="square" anchor="t">
+            <a:spAutoFit/>
+          </a:bodyPr>
+          <a:lstStyle/>
+          <a:p>
+            <a:pPr algn="l"/>
             <a:r>
               <a:rPr sz="1600" b="0">
                 <a:solidFill>
-                  <a:srgbClr val="5A5470"/>
-                </a:solidFill>
-                <a:latin typeface="DIN Next LT W23"/>
-                <a:ea typeface="DIN Next LT W23"/>
-                <a:cs typeface="DIN Next LT W23"/>
-              </a:rPr>
-              <a:t>Labs: code/15- Deep Learning</a:t>
-            </a:r>
-          </a:p>
-        </p:txBody>
-      </p:sp>
-      <p:sp>
-        <p:nvSpPr>
-          <p:cNvPr id="6" name="TextBox 5"/>
-          <p:cNvSpPr txBox="1"/>
-          <p:nvPr/>
-        </p:nvSpPr>
-        <p:spPr>
-          <a:xfrm>
-            <a:off x="548640" y="6126480"/>
-            <a:ext cx="5486400" cy="274320"/>
-          </a:xfrm>
-          <a:prstGeom prst="rect">
-            <a:avLst/>
-          </a:prstGeom>
-          <a:noFill/>
-        </p:spPr>
-        <p:txBody>
-          <a:bodyPr wrap="square" anchor="t">
-            <a:spAutoFit/>
-          </a:bodyPr>
-          <a:lstStyle/>
-          <a:p>
-            <a:pPr algn="l"/>
-            <a:r>
-              <a:rPr sz="1200" b="1">
+                  <a:srgbClr val="121018"/>
+                </a:solidFill>
+                <a:latin typeface="DIN Next LT W23"/>
+                <a:ea typeface="DIN Next LT W23"/>
+                <a:cs typeface="DIN Next LT W23"/>
+              </a:rPr>
+              <a:t>A neuron is z = wᵀx + b then a = f(z). Depth needs nonlinearity between layers.</a:t>
+            </a:r>
+          </a:p>
+        </p:txBody>
+      </p:sp>
+      <p:sp>
+        <p:nvSpPr>
+          <p:cNvPr id="11" name="Rounded Rectangle 10"/>
+          <p:cNvSpPr/>
+          <p:nvPr/>
+        </p:nvSpPr>
+        <p:spPr>
+          <a:xfrm>
+            <a:off x="548640" y="3291840"/>
+            <a:ext cx="10972800" cy="987552"/>
+          </a:xfrm>
+          <a:prstGeom prst="roundRect">
+            <a:avLst>
+              <a:gd name="adj" fmla="val 10000"/>
+            </a:avLst>
+          </a:prstGeom>
+          <a:solidFill>
+            <a:srgbClr val="EEE8FA"/>
+          </a:solidFill>
+          <a:ln>
+            <a:noFill/>
+          </a:ln>
+          <a:effectLst/>
+        </p:spPr>
+        <p:style>
+          <a:lnRef idx="1">
+            <a:schemeClr val="accent1"/>
+          </a:lnRef>
+          <a:fillRef idx="3">
+            <a:schemeClr val="accent1"/>
+          </a:fillRef>
+          <a:effectRef idx="2">
+            <a:schemeClr val="accent1"/>
+          </a:effectRef>
+          <a:fontRef idx="minor">
+            <a:schemeClr val="lt1"/>
+          </a:fontRef>
+        </p:style>
+        <p:txBody>
+          <a:bodyPr rtlCol="0" anchor="ctr"/>
+          <a:lstStyle/>
+          <a:p>
+            <a:pPr algn="ctr"/>
+          </a:p>
+        </p:txBody>
+      </p:sp>
+      <p:sp>
+        <p:nvSpPr>
+          <p:cNvPr id="12" name="TextBox 11"/>
+          <p:cNvSpPr txBox="1"/>
+          <p:nvPr/>
+        </p:nvSpPr>
+        <p:spPr>
+          <a:xfrm>
+            <a:off x="822960" y="3547872"/>
+            <a:ext cx="457200" cy="457200"/>
+          </a:xfrm>
+          <a:prstGeom prst="rect">
+            <a:avLst/>
+          </a:prstGeom>
+          <a:noFill/>
+        </p:spPr>
+        <p:txBody>
+          <a:bodyPr wrap="square" anchor="t">
+            <a:spAutoFit/>
+          </a:bodyPr>
+          <a:lstStyle/>
+          <a:p>
+            <a:pPr algn="l"/>
+            <a:r>
+              <a:rPr sz="2200" b="1">
                 <a:solidFill>
                   <a:srgbClr val="5234B7"/>
                 </a:solidFill>
@@ -50992,14 +51019,171 @@
                 <a:ea typeface="DIN Next LT W23"/>
                 <a:cs typeface="DIN Next LT W23"/>
               </a:rPr>
-              <a:t>ETRA</a:t>
-            </a:r>
-          </a:p>
-        </p:txBody>
-      </p:sp>
-      <p:sp>
-        <p:nvSpPr>
-          <p:cNvPr id="7" name="Rectangle 6"/>
+              <a:t>2</a:t>
+            </a:r>
+          </a:p>
+        </p:txBody>
+      </p:sp>
+      <p:sp>
+        <p:nvSpPr>
+          <p:cNvPr id="13" name="TextBox 12"/>
+          <p:cNvSpPr txBox="1"/>
+          <p:nvPr/>
+        </p:nvSpPr>
+        <p:spPr>
+          <a:xfrm>
+            <a:off x="1417320" y="3547872"/>
+            <a:ext cx="9692640" cy="548640"/>
+          </a:xfrm>
+          <a:prstGeom prst="rect">
+            <a:avLst/>
+          </a:prstGeom>
+          <a:noFill/>
+        </p:spPr>
+        <p:txBody>
+          <a:bodyPr wrap="square" anchor="t">
+            <a:spAutoFit/>
+          </a:bodyPr>
+          <a:lstStyle/>
+          <a:p>
+            <a:pPr algn="l"/>
+            <a:r>
+              <a:rPr sz="1600" b="0">
+                <a:solidFill>
+                  <a:srgbClr val="121018"/>
+                </a:solidFill>
+                <a:latin typeface="DIN Next LT W23"/>
+                <a:ea typeface="DIN Next LT W23"/>
+                <a:cs typeface="DIN Next LT W23"/>
+              </a:rPr>
+              <a:t>Backprop is the chain rule on a graph. Watch vanishing gradients, LR, and train vs val.</a:t>
+            </a:r>
+          </a:p>
+        </p:txBody>
+      </p:sp>
+      <p:sp>
+        <p:nvSpPr>
+          <p:cNvPr id="14" name="Rounded Rectangle 13"/>
+          <p:cNvSpPr/>
+          <p:nvPr/>
+        </p:nvSpPr>
+        <p:spPr>
+          <a:xfrm>
+            <a:off x="548640" y="4434840"/>
+            <a:ext cx="10972800" cy="987552"/>
+          </a:xfrm>
+          <a:prstGeom prst="roundRect">
+            <a:avLst>
+              <a:gd name="adj" fmla="val 10000"/>
+            </a:avLst>
+          </a:prstGeom>
+          <a:solidFill>
+            <a:srgbClr val="EEE8FA"/>
+          </a:solidFill>
+          <a:ln>
+            <a:noFill/>
+          </a:ln>
+          <a:effectLst/>
+        </p:spPr>
+        <p:style>
+          <a:lnRef idx="1">
+            <a:schemeClr val="accent1"/>
+          </a:lnRef>
+          <a:fillRef idx="3">
+            <a:schemeClr val="accent1"/>
+          </a:fillRef>
+          <a:effectRef idx="2">
+            <a:schemeClr val="accent1"/>
+          </a:effectRef>
+          <a:fontRef idx="minor">
+            <a:schemeClr val="lt1"/>
+          </a:fontRef>
+        </p:style>
+        <p:txBody>
+          <a:bodyPr rtlCol="0" anchor="ctr"/>
+          <a:lstStyle/>
+          <a:p>
+            <a:pPr algn="ctr"/>
+          </a:p>
+        </p:txBody>
+      </p:sp>
+      <p:sp>
+        <p:nvSpPr>
+          <p:cNvPr id="15" name="TextBox 14"/>
+          <p:cNvSpPr txBox="1"/>
+          <p:nvPr/>
+        </p:nvSpPr>
+        <p:spPr>
+          <a:xfrm>
+            <a:off x="822960" y="4690872"/>
+            <a:ext cx="457200" cy="457200"/>
+          </a:xfrm>
+          <a:prstGeom prst="rect">
+            <a:avLst/>
+          </a:prstGeom>
+          <a:noFill/>
+        </p:spPr>
+        <p:txBody>
+          <a:bodyPr wrap="square" anchor="t">
+            <a:spAutoFit/>
+          </a:bodyPr>
+          <a:lstStyle/>
+          <a:p>
+            <a:pPr algn="l"/>
+            <a:r>
+              <a:rPr sz="2200" b="1">
+                <a:solidFill>
+                  <a:srgbClr val="5234B7"/>
+                </a:solidFill>
+                <a:latin typeface="DIN Next LT W23"/>
+                <a:ea typeface="DIN Next LT W23"/>
+                <a:cs typeface="DIN Next LT W23"/>
+              </a:rPr>
+              <a:t>3</a:t>
+            </a:r>
+          </a:p>
+        </p:txBody>
+      </p:sp>
+      <p:sp>
+        <p:nvSpPr>
+          <p:cNvPr id="16" name="TextBox 15"/>
+          <p:cNvSpPr txBox="1"/>
+          <p:nvPr/>
+        </p:nvSpPr>
+        <p:spPr>
+          <a:xfrm>
+            <a:off x="1417320" y="4690872"/>
+            <a:ext cx="9692640" cy="548640"/>
+          </a:xfrm>
+          <a:prstGeom prst="rect">
+            <a:avLst/>
+          </a:prstGeom>
+          <a:noFill/>
+        </p:spPr>
+        <p:txBody>
+          <a:bodyPr wrap="square" anchor="t">
+            <a:spAutoFit/>
+          </a:bodyPr>
+          <a:lstStyle/>
+          <a:p>
+            <a:pPr algn="l"/>
+            <a:r>
+              <a:rPr sz="1600" b="0">
+                <a:solidFill>
+                  <a:srgbClr val="121018"/>
+                </a:solidFill>
+                <a:latin typeface="DIN Next LT W23"/>
+                <a:ea typeface="DIN Next LT W23"/>
+                <a:cs typeface="DIN Next LT W23"/>
+              </a:rPr>
+              <a:t>CNNs share filters across space; RNNs share weights across time; regularize so they generalize.</a:t>
+            </a:r>
+          </a:p>
+        </p:txBody>
+      </p:sp>
+      <p:sp>
+        <p:nvSpPr>
+          <p:cNvPr id="17" name="Rectangle 16"/>
           <p:cNvSpPr/>
           <p:nvPr/>
         </p:nvSpPr>
@@ -51043,7 +51227,7 @@
       </p:sp>
       <p:sp>
         <p:nvSpPr>
-          <p:cNvPr id="8" name="TextBox 7"/>
+          <p:cNvPr id="18" name="TextBox 17"/>
           <p:cNvSpPr txBox="1"/>
           <p:nvPr/>
         </p:nvSpPr>
@@ -51080,7 +51264,7 @@
       </p:sp>
       <p:sp>
         <p:nvSpPr>
-          <p:cNvPr id="9" name="TextBox 8"/>
+          <p:cNvPr id="19" name="TextBox 18"/>
           <p:cNvSpPr txBox="1"/>
           <p:nvPr/>
         </p:nvSpPr>
@@ -51110,7 +51294,330 @@
                 <a:ea typeface="DIN Next LT W23"/>
                 <a:cs typeface="DIN Next LT W23"/>
               </a:rPr>
-              <a:t>78  /  78</a:t>
+              <a:t>78  /  79</a:t>
+            </a:r>
+          </a:p>
+        </p:txBody>
+      </p:sp>
+    </p:spTree>
+  </p:cSld>
+  <p:clrMapOvr>
+    <a:masterClrMapping/>
+  </p:clrMapOvr>
+</p:sld>
+</file>
+
+<file path=ppt/slides/slide79.xml><?xml version="1.0" encoding="utf-8"?>
+<p:sld xmlns:a="http://schemas.openxmlformats.org/drawingml/2006/main" xmlns:p="http://schemas.openxmlformats.org/presentationml/2006/main" xmlns:r="http://schemas.openxmlformats.org/officeDocument/2006/relationships">
+  <p:cSld>
+    <p:bg>
+      <p:bgPr>
+        <a:solidFill>
+          <a:srgbClr val="FAF8FF"/>
+        </a:solidFill>
+        <a:effectLst/>
+      </p:bgPr>
+    </p:bg>
+    <p:spTree>
+      <p:nvGrpSpPr>
+        <p:cNvPr id="1" name=""/>
+        <p:cNvGrpSpPr/>
+        <p:nvPr/>
+      </p:nvGrpSpPr>
+      <p:grpSpPr/>
+      <p:sp>
+        <p:nvSpPr>
+          <p:cNvPr id="2" name="Rectangle 1"/>
+          <p:cNvSpPr/>
+          <p:nvPr/>
+        </p:nvSpPr>
+        <p:spPr>
+          <a:xfrm>
+            <a:off x="12136831" y="0"/>
+            <a:ext cx="54864" cy="6858000"/>
+          </a:xfrm>
+          <a:prstGeom prst="rect">
+            <a:avLst/>
+          </a:prstGeom>
+          <a:solidFill>
+            <a:srgbClr val="5234B7"/>
+          </a:solidFill>
+          <a:ln>
+            <a:noFill/>
+          </a:ln>
+          <a:effectLst/>
+        </p:spPr>
+        <p:style>
+          <a:lnRef idx="1">
+            <a:schemeClr val="accent1"/>
+          </a:lnRef>
+          <a:fillRef idx="3">
+            <a:schemeClr val="accent1"/>
+          </a:fillRef>
+          <a:effectRef idx="2">
+            <a:schemeClr val="accent1"/>
+          </a:effectRef>
+          <a:fontRef idx="minor">
+            <a:schemeClr val="lt1"/>
+          </a:fontRef>
+        </p:style>
+        <p:txBody>
+          <a:bodyPr rtlCol="0" anchor="ctr"/>
+          <a:lstStyle/>
+          <a:p>
+            <a:pPr algn="ctr"/>
+          </a:p>
+        </p:txBody>
+      </p:sp>
+      <p:pic>
+        <p:nvPicPr>
+          <p:cNvPr id="3" name="Picture 2" descr="etra-wordmark.png"/>
+          <p:cNvPicPr>
+            <a:picLocks noChangeAspect="1"/>
+          </p:cNvPicPr>
+          <p:nvPr/>
+        </p:nvPicPr>
+        <p:blipFill>
+          <a:blip r:embed="rId2"/>
+          <a:stretch>
+            <a:fillRect/>
+          </a:stretch>
+        </p:blipFill>
+        <p:spPr>
+          <a:xfrm>
+            <a:off x="10561320" y="411480"/>
+            <a:ext cx="1378516" cy="365760"/>
+          </a:xfrm>
+          <a:prstGeom prst="rect">
+            <a:avLst/>
+          </a:prstGeom>
+        </p:spPr>
+      </p:pic>
+      <p:sp>
+        <p:nvSpPr>
+          <p:cNvPr id="4" name="TextBox 3"/>
+          <p:cNvSpPr txBox="1"/>
+          <p:nvPr/>
+        </p:nvSpPr>
+        <p:spPr>
+          <a:xfrm>
+            <a:off x="548640" y="2651760"/>
+            <a:ext cx="10972800" cy="731520"/>
+          </a:xfrm>
+          <a:prstGeom prst="rect">
+            <a:avLst/>
+          </a:prstGeom>
+          <a:noFill/>
+        </p:spPr>
+        <p:txBody>
+          <a:bodyPr wrap="square" anchor="t">
+            <a:spAutoFit/>
+          </a:bodyPr>
+          <a:lstStyle/>
+          <a:p>
+            <a:pPr algn="ctr"/>
+            <a:r>
+              <a:rPr sz="4000" b="1">
+                <a:solidFill>
+                  <a:srgbClr val="5234B7"/>
+                </a:solidFill>
+                <a:latin typeface="DIN Next LT W23"/>
+                <a:ea typeface="DIN Next LT W23"/>
+                <a:cs typeface="DIN Next LT W23"/>
+              </a:rPr>
+              <a:t>Thank you</a:t>
+            </a:r>
+          </a:p>
+        </p:txBody>
+      </p:sp>
+      <p:sp>
+        <p:nvSpPr>
+          <p:cNvPr id="5" name="TextBox 4"/>
+          <p:cNvSpPr txBox="1"/>
+          <p:nvPr/>
+        </p:nvSpPr>
+        <p:spPr>
+          <a:xfrm>
+            <a:off x="548640" y="3474720"/>
+            <a:ext cx="10972800" cy="365760"/>
+          </a:xfrm>
+          <a:prstGeom prst="rect">
+            <a:avLst/>
+          </a:prstGeom>
+          <a:noFill/>
+        </p:spPr>
+        <p:txBody>
+          <a:bodyPr wrap="square" anchor="t">
+            <a:spAutoFit/>
+          </a:bodyPr>
+          <a:lstStyle/>
+          <a:p>
+            <a:pPr algn="ctr"/>
+            <a:r>
+              <a:rPr sz="1600" b="0">
+                <a:solidFill>
+                  <a:srgbClr val="5A5470"/>
+                </a:solidFill>
+                <a:latin typeface="DIN Next LT W23"/>
+                <a:ea typeface="DIN Next LT W23"/>
+                <a:cs typeface="DIN Next LT W23"/>
+              </a:rPr>
+              <a:t>Labs: code/15- Deep Learning</a:t>
+            </a:r>
+          </a:p>
+        </p:txBody>
+      </p:sp>
+      <p:sp>
+        <p:nvSpPr>
+          <p:cNvPr id="6" name="TextBox 5"/>
+          <p:cNvSpPr txBox="1"/>
+          <p:nvPr/>
+        </p:nvSpPr>
+        <p:spPr>
+          <a:xfrm>
+            <a:off x="548640" y="6126480"/>
+            <a:ext cx="5486400" cy="274320"/>
+          </a:xfrm>
+          <a:prstGeom prst="rect">
+            <a:avLst/>
+          </a:prstGeom>
+          <a:noFill/>
+        </p:spPr>
+        <p:txBody>
+          <a:bodyPr wrap="square" anchor="t">
+            <a:spAutoFit/>
+          </a:bodyPr>
+          <a:lstStyle/>
+          <a:p>
+            <a:pPr algn="l"/>
+            <a:r>
+              <a:rPr sz="1200" b="1">
+                <a:solidFill>
+                  <a:srgbClr val="5234B7"/>
+                </a:solidFill>
+                <a:latin typeface="DIN Next LT W23"/>
+                <a:ea typeface="DIN Next LT W23"/>
+                <a:cs typeface="DIN Next LT W23"/>
+              </a:rPr>
+              <a:t>ETRA</a:t>
+            </a:r>
+          </a:p>
+        </p:txBody>
+      </p:sp>
+      <p:sp>
+        <p:nvSpPr>
+          <p:cNvPr id="7" name="Rectangle 6"/>
+          <p:cNvSpPr/>
+          <p:nvPr/>
+        </p:nvSpPr>
+        <p:spPr>
+          <a:xfrm>
+            <a:off x="548640" y="6446520"/>
+            <a:ext cx="11064240" cy="10972"/>
+          </a:xfrm>
+          <a:prstGeom prst="rect">
+            <a:avLst/>
+          </a:prstGeom>
+          <a:solidFill>
+            <a:srgbClr val="5234B7"/>
+          </a:solidFill>
+          <a:ln>
+            <a:noFill/>
+          </a:ln>
+          <a:effectLst/>
+        </p:spPr>
+        <p:style>
+          <a:lnRef idx="1">
+            <a:schemeClr val="accent1"/>
+          </a:lnRef>
+          <a:fillRef idx="3">
+            <a:schemeClr val="accent1"/>
+          </a:fillRef>
+          <a:effectRef idx="2">
+            <a:schemeClr val="accent1"/>
+          </a:effectRef>
+          <a:fontRef idx="minor">
+            <a:schemeClr val="lt1"/>
+          </a:fontRef>
+        </p:style>
+        <p:txBody>
+          <a:bodyPr rtlCol="0" anchor="ctr"/>
+          <a:lstStyle/>
+          <a:p>
+            <a:pPr algn="ctr"/>
+          </a:p>
+        </p:txBody>
+      </p:sp>
+      <p:sp>
+        <p:nvSpPr>
+          <p:cNvPr id="8" name="TextBox 7"/>
+          <p:cNvSpPr txBox="1"/>
+          <p:nvPr/>
+        </p:nvSpPr>
+        <p:spPr>
+          <a:xfrm>
+            <a:off x="548640" y="6510528"/>
+            <a:ext cx="2743200" cy="256032"/>
+          </a:xfrm>
+          <a:prstGeom prst="rect">
+            <a:avLst/>
+          </a:prstGeom>
+          <a:noFill/>
+        </p:spPr>
+        <p:txBody>
+          <a:bodyPr wrap="square" anchor="t">
+            <a:spAutoFit/>
+          </a:bodyPr>
+          <a:lstStyle/>
+          <a:p>
+            <a:pPr algn="l"/>
+            <a:r>
+              <a:rPr sz="1100" b="1">
+                <a:solidFill>
+                  <a:srgbClr val="5234B7"/>
+                </a:solidFill>
+                <a:latin typeface="DIN Next LT W23"/>
+                <a:ea typeface="DIN Next LT W23"/>
+                <a:cs typeface="DIN Next LT W23"/>
+              </a:rPr>
+              <a:t>ETRA</a:t>
+            </a:r>
+          </a:p>
+        </p:txBody>
+      </p:sp>
+      <p:sp>
+        <p:nvSpPr>
+          <p:cNvPr id="9" name="TextBox 8"/>
+          <p:cNvSpPr txBox="1"/>
+          <p:nvPr/>
+        </p:nvSpPr>
+        <p:spPr>
+          <a:xfrm>
+            <a:off x="9601200" y="6510528"/>
+            <a:ext cx="2011680" cy="256032"/>
+          </a:xfrm>
+          <a:prstGeom prst="rect">
+            <a:avLst/>
+          </a:prstGeom>
+          <a:noFill/>
+        </p:spPr>
+        <p:txBody>
+          <a:bodyPr wrap="square" anchor="t">
+            <a:spAutoFit/>
+          </a:bodyPr>
+          <a:lstStyle/>
+          <a:p>
+            <a:pPr algn="r"/>
+            <a:r>
+              <a:rPr sz="1100" b="0">
+                <a:solidFill>
+                  <a:srgbClr val="5A5470"/>
+                </a:solidFill>
+                <a:latin typeface="DIN Next LT W23"/>
+                <a:ea typeface="DIN Next LT W23"/>
+                <a:cs typeface="DIN Next LT W23"/>
+              </a:rPr>
+              <a:t>79  /  79</a:t>
             </a:r>
           </a:p>
         </p:txBody>
@@ -51778,7 +52285,7 @@
                 <a:ea typeface="DIN Next LT W23"/>
                 <a:cs typeface="DIN Next LT W23"/>
               </a:rPr>
-              <a:t>08  /  78</a:t>
+              <a:t>08  /  79</a:t>
             </a:r>
           </a:p>
         </p:txBody>
@@ -52409,7 +52916,7 @@
                 <a:ea typeface="DIN Next LT W23"/>
                 <a:cs typeface="DIN Next LT W23"/>
               </a:rPr>
-              <a:t>09  /  78</a:t>
+              <a:t>09  /  79</a:t>
             </a:r>
           </a:p>
         </p:txBody>

</xml_diff>